<commit_message>
docs: align technical report, presentation, and voiceover scripts with verified metrics
</commit_message>
<xml_diff>
--- a/Deliverables/The_Secret_Library_Presentation.pptx
+++ b/Deliverables/The_Secret_Library_Presentation.pptx
@@ -7107,11 +7107,7 @@
               </a:defRPr>
             </a:pPr>
             <a:r>
-              <a:rPr dirty="0">
-                <a:latin typeface="Times New Roman" panose="02020603050405020304" pitchFamily="18" charset="0"/>
-                <a:cs typeface="Times New Roman" panose="02020603050405020304" pitchFamily="18" charset="0"/>
-              </a:rPr>
-              <a:t>Procedural Primitives</a:t>
+              <a:t>• Πραγματικές Μετρήσεις RenderingServer: Μόλις 68 Draw Calls, 89 Objects, 1.8M Primitives.</a:t>
             </a:r>
           </a:p>
           <a:p>
@@ -10159,18 +10155,7 @@
               </a:defRPr>
             </a:pPr>
             <a:r>
-              <a:rPr dirty="0">
-                <a:latin typeface="Times New Roman" panose="02020603050405020304" pitchFamily="18" charset="0"/>
-                <a:cs typeface="Times New Roman" panose="02020603050405020304" pitchFamily="18" charset="0"/>
-              </a:rPr>
-              <a:t>🏃 </a:t>
-            </a:r>
-            <a:r>
-              <a:rPr dirty="0" err="1">
-                <a:latin typeface="Times New Roman" panose="02020603050405020304" pitchFamily="18" charset="0"/>
-                <a:cs typeface="Times New Roman" panose="02020603050405020304" pitchFamily="18" charset="0"/>
-              </a:rPr>
-              <a:t>player.gd</a:t>
+              <a:t>🏃 player.gd: 266 Γραμμές (Input Actions, Input.get_vector, 3.0m reach, ✋ crosshair, door check)</a:t>
             </a:r>
             <a:endParaRPr dirty="0">
               <a:latin typeface="Times New Roman" panose="02020603050405020304" pitchFamily="18" charset="0"/>
@@ -10189,53 +10174,7 @@
               </a:defRPr>
             </a:pPr>
             <a:r>
-              <a:rPr dirty="0">
-                <a:latin typeface="Times New Roman" panose="02020603050405020304" pitchFamily="18" charset="0"/>
-                <a:cs typeface="Times New Roman" panose="02020603050405020304" pitchFamily="18" charset="0"/>
-              </a:rPr>
-              <a:t>180 </a:t>
-            </a:r>
-            <a:r>
-              <a:rPr dirty="0" err="1">
-                <a:latin typeface="Times New Roman" panose="02020603050405020304" pitchFamily="18" charset="0"/>
-                <a:cs typeface="Times New Roman" panose="02020603050405020304" pitchFamily="18" charset="0"/>
-              </a:rPr>
-              <a:t>Γρ</a:t>
-            </a:r>
-            <a:r>
-              <a:rPr dirty="0">
-                <a:latin typeface="Times New Roman" panose="02020603050405020304" pitchFamily="18" charset="0"/>
-                <a:cs typeface="Times New Roman" panose="02020603050405020304" pitchFamily="18" charset="0"/>
-              </a:rPr>
-              <a:t>α</a:t>
-            </a:r>
-            <a:r>
-              <a:rPr dirty="0" err="1">
-                <a:latin typeface="Times New Roman" panose="02020603050405020304" pitchFamily="18" charset="0"/>
-                <a:cs typeface="Times New Roman" panose="02020603050405020304" pitchFamily="18" charset="0"/>
-              </a:rPr>
-              <a:t>μμές</a:t>
-            </a:r>
-            <a:r>
-              <a:rPr dirty="0">
-                <a:latin typeface="Times New Roman" panose="02020603050405020304" pitchFamily="18" charset="0"/>
-                <a:cs typeface="Times New Roman" panose="02020603050405020304" pitchFamily="18" charset="0"/>
-              </a:rPr>
-              <a:t> </a:t>
-            </a:r>
-            <a:r>
-              <a:rPr dirty="0" err="1">
-                <a:latin typeface="Times New Roman" panose="02020603050405020304" pitchFamily="18" charset="0"/>
-                <a:cs typeface="Times New Roman" panose="02020603050405020304" pitchFamily="18" charset="0"/>
-              </a:rPr>
-              <a:t>Κώδικ</a:t>
-            </a:r>
-            <a:r>
-              <a:rPr dirty="0">
-                <a:latin typeface="Times New Roman" panose="02020603050405020304" pitchFamily="18" charset="0"/>
-                <a:cs typeface="Times New Roman" panose="02020603050405020304" pitchFamily="18" charset="0"/>
-              </a:rPr>
-              <a:t>α</a:t>
+              <a:t>266 Γραμμές Κώδικα</a:t>
             </a:r>
           </a:p>
           <a:p>
@@ -10398,18 +10337,7 @@
               </a:defRPr>
             </a:pPr>
             <a:r>
-              <a:rPr dirty="0">
-                <a:latin typeface="Times New Roman" panose="02020603050405020304" pitchFamily="18" charset="0"/>
-                <a:cs typeface="Times New Roman" panose="02020603050405020304" pitchFamily="18" charset="0"/>
-              </a:rPr>
-              <a:t>🧠 </a:t>
-            </a:r>
-            <a:r>
-              <a:rPr dirty="0" err="1">
-                <a:latin typeface="Times New Roman" panose="02020603050405020304" pitchFamily="18" charset="0"/>
-                <a:cs typeface="Times New Roman" panose="02020603050405020304" pitchFamily="18" charset="0"/>
-              </a:rPr>
-              <a:t>game_manager.gd</a:t>
+              <a:t>⚙️ game_manager.gd: 406 Γραμμές (240-book MultiMesh, triangle puzzle logic, atmospheric tweens)</a:t>
             </a:r>
             <a:endParaRPr dirty="0">
               <a:latin typeface="Times New Roman" panose="02020603050405020304" pitchFamily="18" charset="0"/>
@@ -21030,11 +20958,7 @@
               </a:defRPr>
             </a:pPr>
             <a:r>
-              <a:rPr dirty="0">
-                <a:latin typeface="Times New Roman" panose="02020603050405020304" pitchFamily="18" charset="0"/>
-                <a:cs typeface="Times New Roman" panose="02020603050405020304" pitchFamily="18" charset="0"/>
-              </a:rPr>
-              <a:t>RayCast3D, Signals &amp; Adaptive Crosshair</a:t>
+              <a:t>• Δυναμικό Στόχαστρο: Αυτόματη μετατροπή από + σε χρυσό ✋ κατά την εστίαση σε interactable.</a:t>
             </a:r>
           </a:p>
         </p:txBody>
@@ -21138,151 +21062,7 @@
               </a:defRPr>
             </a:pPr>
             <a:r>
-              <a:rPr dirty="0">
-                <a:latin typeface="Times New Roman" panose="02020603050405020304" pitchFamily="18" charset="0"/>
-                <a:cs typeface="Times New Roman" panose="02020603050405020304" pitchFamily="18" charset="0"/>
-              </a:rPr>
-              <a:t>• </a:t>
-            </a:r>
-            <a:r>
-              <a:rPr dirty="0" err="1">
-                <a:latin typeface="Times New Roman" panose="02020603050405020304" pitchFamily="18" charset="0"/>
-                <a:cs typeface="Times New Roman" panose="02020603050405020304" pitchFamily="18" charset="0"/>
-              </a:rPr>
-              <a:t>Ακτίν</a:t>
-            </a:r>
-            <a:r>
-              <a:rPr dirty="0">
-                <a:latin typeface="Times New Roman" panose="02020603050405020304" pitchFamily="18" charset="0"/>
-                <a:cs typeface="Times New Roman" panose="02020603050405020304" pitchFamily="18" charset="0"/>
-              </a:rPr>
-              <a:t>α </a:t>
-            </a:r>
-            <a:r>
-              <a:rPr dirty="0" err="1">
-                <a:latin typeface="Times New Roman" panose="02020603050405020304" pitchFamily="18" charset="0"/>
-                <a:cs typeface="Times New Roman" panose="02020603050405020304" pitchFamily="18" charset="0"/>
-              </a:rPr>
-              <a:t>Ανίχνευσης</a:t>
-            </a:r>
-            <a:r>
-              <a:rPr dirty="0">
-                <a:latin typeface="Times New Roman" panose="02020603050405020304" pitchFamily="18" charset="0"/>
-                <a:cs typeface="Times New Roman" panose="02020603050405020304" pitchFamily="18" charset="0"/>
-              </a:rPr>
-              <a:t>: </a:t>
-            </a:r>
-            <a:r>
-              <a:rPr dirty="0" err="1">
-                <a:latin typeface="Times New Roman" panose="02020603050405020304" pitchFamily="18" charset="0"/>
-                <a:cs typeface="Times New Roman" panose="02020603050405020304" pitchFamily="18" charset="0"/>
-              </a:rPr>
-              <a:t>Μήκους</a:t>
-            </a:r>
-            <a:r>
-              <a:rPr dirty="0">
-                <a:latin typeface="Times New Roman" panose="02020603050405020304" pitchFamily="18" charset="0"/>
-                <a:cs typeface="Times New Roman" panose="02020603050405020304" pitchFamily="18" charset="0"/>
-              </a:rPr>
-              <a:t> 2.5 </a:t>
-            </a:r>
-            <a:r>
-              <a:rPr dirty="0" err="1">
-                <a:latin typeface="Times New Roman" panose="02020603050405020304" pitchFamily="18" charset="0"/>
-                <a:cs typeface="Times New Roman" panose="02020603050405020304" pitchFamily="18" charset="0"/>
-              </a:rPr>
-              <a:t>μέτρων</a:t>
-            </a:r>
-            <a:r>
-              <a:rPr dirty="0">
-                <a:latin typeface="Times New Roman" panose="02020603050405020304" pitchFamily="18" charset="0"/>
-                <a:cs typeface="Times New Roman" panose="02020603050405020304" pitchFamily="18" charset="0"/>
-              </a:rPr>
-              <a:t> απ</a:t>
-            </a:r>
-            <a:r>
-              <a:rPr dirty="0" err="1">
-                <a:latin typeface="Times New Roman" panose="02020603050405020304" pitchFamily="18" charset="0"/>
-                <a:cs typeface="Times New Roman" panose="02020603050405020304" pitchFamily="18" charset="0"/>
-              </a:rPr>
-              <a:t>ό</a:t>
-            </a:r>
-            <a:r>
-              <a:rPr dirty="0">
-                <a:latin typeface="Times New Roman" panose="02020603050405020304" pitchFamily="18" charset="0"/>
-                <a:cs typeface="Times New Roman" panose="02020603050405020304" pitchFamily="18" charset="0"/>
-              </a:rPr>
-              <a:t> </a:t>
-            </a:r>
-            <a:r>
-              <a:rPr dirty="0" err="1">
-                <a:latin typeface="Times New Roman" panose="02020603050405020304" pitchFamily="18" charset="0"/>
-                <a:cs typeface="Times New Roman" panose="02020603050405020304" pitchFamily="18" charset="0"/>
-              </a:rPr>
-              <a:t>το</a:t>
-            </a:r>
-            <a:r>
-              <a:rPr dirty="0">
-                <a:latin typeface="Times New Roman" panose="02020603050405020304" pitchFamily="18" charset="0"/>
-                <a:cs typeface="Times New Roman" panose="02020603050405020304" pitchFamily="18" charset="0"/>
-              </a:rPr>
-              <a:t> </a:t>
-            </a:r>
-            <a:r>
-              <a:rPr dirty="0" err="1">
-                <a:latin typeface="Times New Roman" panose="02020603050405020304" pitchFamily="18" charset="0"/>
-                <a:cs typeface="Times New Roman" panose="02020603050405020304" pitchFamily="18" charset="0"/>
-              </a:rPr>
-              <a:t>κέντρο</a:t>
-            </a:r>
-            <a:r>
-              <a:rPr dirty="0">
-                <a:latin typeface="Times New Roman" panose="02020603050405020304" pitchFamily="18" charset="0"/>
-                <a:cs typeface="Times New Roman" panose="02020603050405020304" pitchFamily="18" charset="0"/>
-              </a:rPr>
-              <a:t> </a:t>
-            </a:r>
-            <a:r>
-              <a:rPr dirty="0" err="1">
-                <a:latin typeface="Times New Roman" panose="02020603050405020304" pitchFamily="18" charset="0"/>
-                <a:cs typeface="Times New Roman" panose="02020603050405020304" pitchFamily="18" charset="0"/>
-              </a:rPr>
-              <a:t>της</a:t>
-            </a:r>
-            <a:r>
-              <a:rPr dirty="0">
-                <a:latin typeface="Times New Roman" panose="02020603050405020304" pitchFamily="18" charset="0"/>
-                <a:cs typeface="Times New Roman" panose="02020603050405020304" pitchFamily="18" charset="0"/>
-              </a:rPr>
-              <a:t> </a:t>
-            </a:r>
-            <a:r>
-              <a:rPr dirty="0" err="1">
-                <a:latin typeface="Times New Roman" panose="02020603050405020304" pitchFamily="18" charset="0"/>
-                <a:cs typeface="Times New Roman" panose="02020603050405020304" pitchFamily="18" charset="0"/>
-              </a:rPr>
-              <a:t>κάμερ</a:t>
-            </a:r>
-            <a:r>
-              <a:rPr dirty="0">
-                <a:latin typeface="Times New Roman" panose="02020603050405020304" pitchFamily="18" charset="0"/>
-                <a:cs typeface="Times New Roman" panose="02020603050405020304" pitchFamily="18" charset="0"/>
-              </a:rPr>
-              <a:t>α</a:t>
-            </a:r>
-            <a:r>
-              <a:rPr dirty="0" err="1">
-                <a:latin typeface="Times New Roman" panose="02020603050405020304" pitchFamily="18" charset="0"/>
-                <a:cs typeface="Times New Roman" panose="02020603050405020304" pitchFamily="18" charset="0"/>
-              </a:rPr>
-              <a:t>ς</a:t>
-            </a:r>
-            <a:r>
-              <a:rPr dirty="0">
-                <a:latin typeface="Times New Roman" panose="02020603050405020304" pitchFamily="18" charset="0"/>
-                <a:cs typeface="Times New Roman" panose="02020603050405020304" pitchFamily="18" charset="0"/>
-              </a:rPr>
-              <a:t>.</a:t>
+              <a:t>• Ακτίνα Ανίχνευσης: Μήκους 3.0 μέτρων από το κέντρο της κάμερας.</a:t>
             </a:r>
           </a:p>
           <a:p>
@@ -25488,165 +25268,7 @@
               </a:defRPr>
             </a:pPr>
             <a:r>
-              <a:rPr dirty="0">
-                <a:latin typeface="Times New Roman" panose="02020603050405020304" pitchFamily="18" charset="0"/>
-                <a:cs typeface="Times New Roman" panose="02020603050405020304" pitchFamily="18" charset="0"/>
-              </a:rPr>
-              <a:t>• </a:t>
-            </a:r>
-            <a:r>
-              <a:rPr dirty="0" err="1">
-                <a:latin typeface="Times New Roman" panose="02020603050405020304" pitchFamily="18" charset="0"/>
-                <a:cs typeface="Times New Roman" panose="02020603050405020304" pitchFamily="18" charset="0"/>
-              </a:rPr>
-              <a:t>Τυχ</a:t>
-            </a:r>
-            <a:r>
-              <a:rPr dirty="0">
-                <a:latin typeface="Times New Roman" panose="02020603050405020304" pitchFamily="18" charset="0"/>
-                <a:cs typeface="Times New Roman" panose="02020603050405020304" pitchFamily="18" charset="0"/>
-              </a:rPr>
-              <a:t>α</a:t>
-            </a:r>
-            <a:r>
-              <a:rPr dirty="0" err="1">
-                <a:latin typeface="Times New Roman" panose="02020603050405020304" pitchFamily="18" charset="0"/>
-                <a:cs typeface="Times New Roman" panose="02020603050405020304" pitchFamily="18" charset="0"/>
-              </a:rPr>
-              <a:t>ίες</a:t>
-            </a:r>
-            <a:r>
-              <a:rPr dirty="0">
-                <a:latin typeface="Times New Roman" panose="02020603050405020304" pitchFamily="18" charset="0"/>
-                <a:cs typeface="Times New Roman" panose="02020603050405020304" pitchFamily="18" charset="0"/>
-              </a:rPr>
-              <a:t> </a:t>
-            </a:r>
-            <a:r>
-              <a:rPr dirty="0" err="1">
-                <a:latin typeface="Times New Roman" panose="02020603050405020304" pitchFamily="18" charset="0"/>
-                <a:cs typeface="Times New Roman" panose="02020603050405020304" pitchFamily="18" charset="0"/>
-              </a:rPr>
-              <a:t>Αρχικές</a:t>
-            </a:r>
-            <a:r>
-              <a:rPr dirty="0">
-                <a:latin typeface="Times New Roman" panose="02020603050405020304" pitchFamily="18" charset="0"/>
-                <a:cs typeface="Times New Roman" panose="02020603050405020304" pitchFamily="18" charset="0"/>
-              </a:rPr>
-              <a:t> </a:t>
-            </a:r>
-            <a:r>
-              <a:rPr dirty="0" err="1">
-                <a:latin typeface="Times New Roman" panose="02020603050405020304" pitchFamily="18" charset="0"/>
-                <a:cs typeface="Times New Roman" panose="02020603050405020304" pitchFamily="18" charset="0"/>
-              </a:rPr>
-              <a:t>Γωνίες</a:t>
-            </a:r>
-            <a:r>
-              <a:rPr dirty="0">
-                <a:latin typeface="Times New Roman" panose="02020603050405020304" pitchFamily="18" charset="0"/>
-                <a:cs typeface="Times New Roman" panose="02020603050405020304" pitchFamily="18" charset="0"/>
-              </a:rPr>
-              <a:t>: </a:t>
-            </a:r>
-            <a:r>
-              <a:rPr dirty="0" err="1">
-                <a:latin typeface="Times New Roman" panose="02020603050405020304" pitchFamily="18" charset="0"/>
-                <a:cs typeface="Times New Roman" panose="02020603050405020304" pitchFamily="18" charset="0"/>
-              </a:rPr>
-              <a:t>Οι</a:t>
-            </a:r>
-            <a:r>
-              <a:rPr dirty="0">
-                <a:latin typeface="Times New Roman" panose="02020603050405020304" pitchFamily="18" charset="0"/>
-                <a:cs typeface="Times New Roman" panose="02020603050405020304" pitchFamily="18" charset="0"/>
-              </a:rPr>
-              <a:t> </a:t>
-            </a:r>
-            <a:r>
-              <a:rPr dirty="0" err="1">
-                <a:latin typeface="Times New Roman" panose="02020603050405020304" pitchFamily="18" charset="0"/>
-                <a:cs typeface="Times New Roman" panose="02020603050405020304" pitchFamily="18" charset="0"/>
-              </a:rPr>
-              <a:t>ρά</a:t>
-            </a:r>
-            <a:r>
-              <a:rPr dirty="0">
-                <a:latin typeface="Times New Roman" panose="02020603050405020304" pitchFamily="18" charset="0"/>
-                <a:cs typeface="Times New Roman" panose="02020603050405020304" pitchFamily="18" charset="0"/>
-              </a:rPr>
-              <a:t>β</a:t>
-            </a:r>
-            <a:r>
-              <a:rPr dirty="0" err="1">
-                <a:latin typeface="Times New Roman" panose="02020603050405020304" pitchFamily="18" charset="0"/>
-                <a:cs typeface="Times New Roman" panose="02020603050405020304" pitchFamily="18" charset="0"/>
-              </a:rPr>
-              <a:t>δοι</a:t>
-            </a:r>
-            <a:r>
-              <a:rPr dirty="0">
-                <a:latin typeface="Times New Roman" panose="02020603050405020304" pitchFamily="18" charset="0"/>
-                <a:cs typeface="Times New Roman" panose="02020603050405020304" pitchFamily="18" charset="0"/>
-              </a:rPr>
-              <a:t> </a:t>
-            </a:r>
-            <a:r>
-              <a:rPr dirty="0" err="1">
-                <a:latin typeface="Times New Roman" panose="02020603050405020304" pitchFamily="18" charset="0"/>
-                <a:cs typeface="Times New Roman" panose="02020603050405020304" pitchFamily="18" charset="0"/>
-              </a:rPr>
-              <a:t>ξεκινούν</a:t>
-            </a:r>
-            <a:r>
-              <a:rPr dirty="0">
-                <a:latin typeface="Times New Roman" panose="02020603050405020304" pitchFamily="18" charset="0"/>
-                <a:cs typeface="Times New Roman" panose="02020603050405020304" pitchFamily="18" charset="0"/>
-              </a:rPr>
-              <a:t> α</a:t>
-            </a:r>
-            <a:r>
-              <a:rPr dirty="0" err="1">
-                <a:latin typeface="Times New Roman" panose="02020603050405020304" pitchFamily="18" charset="0"/>
-                <a:cs typeface="Times New Roman" panose="02020603050405020304" pitchFamily="18" charset="0"/>
-              </a:rPr>
-              <a:t>ν</a:t>
-            </a:r>
-            <a:r>
-              <a:rPr dirty="0">
-                <a:latin typeface="Times New Roman" panose="02020603050405020304" pitchFamily="18" charset="0"/>
-                <a:cs typeface="Times New Roman" panose="02020603050405020304" pitchFamily="18" charset="0"/>
-              </a:rPr>
-              <a:t>α</a:t>
-            </a:r>
-            <a:r>
-              <a:rPr dirty="0" err="1">
-                <a:latin typeface="Times New Roman" panose="02020603050405020304" pitchFamily="18" charset="0"/>
-                <a:cs typeface="Times New Roman" panose="02020603050405020304" pitchFamily="18" charset="0"/>
-              </a:rPr>
-              <a:t>κ</a:t>
-            </a:r>
-            <a:r>
-              <a:rPr dirty="0">
-                <a:latin typeface="Times New Roman" panose="02020603050405020304" pitchFamily="18" charset="0"/>
-                <a:cs typeface="Times New Roman" panose="02020603050405020304" pitchFamily="18" charset="0"/>
-              </a:rPr>
-              <a:t>α</a:t>
-            </a:r>
-            <a:r>
-              <a:rPr dirty="0" err="1">
-                <a:latin typeface="Times New Roman" panose="02020603050405020304" pitchFamily="18" charset="0"/>
-                <a:cs typeface="Times New Roman" panose="02020603050405020304" pitchFamily="18" charset="0"/>
-              </a:rPr>
-              <a:t>τεμένες</a:t>
-            </a:r>
-            <a:r>
-              <a:rPr dirty="0">
-                <a:latin typeface="Times New Roman" panose="02020603050405020304" pitchFamily="18" charset="0"/>
-                <a:cs typeface="Times New Roman" panose="02020603050405020304" pitchFamily="18" charset="0"/>
-              </a:rPr>
-              <a:t> (120°, 0°, 60°).</a:t>
+              <a:t>• Μη Λυμένη Αρχικοποίηση: Οι ράβδοι ξεκινούν στις γωνίες [0.0°, 180.0°, 60.0°] (μη λυμένη κατάσταση).</a:t>
             </a:r>
           </a:p>
           <a:p>

</xml_diff>

<commit_message>
docs(deliverables): update link.txt, voiceover script, report, and presentation
</commit_message>
<xml_diff>
--- a/Deliverables/The_Secret_Library_Presentation.pptx
+++ b/Deliverables/The_Secret_Library_Presentation.pptx
@@ -7107,7 +7107,11 @@
               </a:defRPr>
             </a:pPr>
             <a:r>
-              <a:t>• Πραγματικές Μετρήσεις RenderingServer: Μόλις 68 Draw Calls, 89 Objects, 1.8M Primitives.</a:t>
+              <a:rPr dirty="0">
+                <a:latin typeface="Times New Roman" panose="02020603050405020304" pitchFamily="18" charset="0"/>
+                <a:cs typeface="Times New Roman" panose="02020603050405020304" pitchFamily="18" charset="0"/>
+              </a:rPr>
+              <a:t>Procedural Primitives</a:t>
             </a:r>
           </a:p>
           <a:p>
@@ -10155,7 +10159,18 @@
               </a:defRPr>
             </a:pPr>
             <a:r>
-              <a:t>🏃 player.gd: 266 Γραμμές (Input Actions, Input.get_vector, 3.0m reach, ✋ crosshair, door check)</a:t>
+              <a:rPr dirty="0">
+                <a:latin typeface="Times New Roman" panose="02020603050405020304" pitchFamily="18" charset="0"/>
+                <a:cs typeface="Times New Roman" panose="02020603050405020304" pitchFamily="18" charset="0"/>
+              </a:rPr>
+              <a:t>🏃 </a:t>
+            </a:r>
+            <a:r>
+              <a:rPr dirty="0" err="1">
+                <a:latin typeface="Times New Roman" panose="02020603050405020304" pitchFamily="18" charset="0"/>
+                <a:cs typeface="Times New Roman" panose="02020603050405020304" pitchFamily="18" charset="0"/>
+              </a:rPr>
+              <a:t>player.gd</a:t>
             </a:r>
             <a:endParaRPr dirty="0">
               <a:latin typeface="Times New Roman" panose="02020603050405020304" pitchFamily="18" charset="0"/>
@@ -10174,7 +10189,53 @@
               </a:defRPr>
             </a:pPr>
             <a:r>
-              <a:t>266 Γραμμές Κώδικα</a:t>
+              <a:rPr dirty="0">
+                <a:latin typeface="Times New Roman" panose="02020603050405020304" pitchFamily="18" charset="0"/>
+                <a:cs typeface="Times New Roman" panose="02020603050405020304" pitchFamily="18" charset="0"/>
+              </a:rPr>
+              <a:t>180 </a:t>
+            </a:r>
+            <a:r>
+              <a:rPr dirty="0" err="1">
+                <a:latin typeface="Times New Roman" panose="02020603050405020304" pitchFamily="18" charset="0"/>
+                <a:cs typeface="Times New Roman" panose="02020603050405020304" pitchFamily="18" charset="0"/>
+              </a:rPr>
+              <a:t>Γρ</a:t>
+            </a:r>
+            <a:r>
+              <a:rPr dirty="0">
+                <a:latin typeface="Times New Roman" panose="02020603050405020304" pitchFamily="18" charset="0"/>
+                <a:cs typeface="Times New Roman" panose="02020603050405020304" pitchFamily="18" charset="0"/>
+              </a:rPr>
+              <a:t>α</a:t>
+            </a:r>
+            <a:r>
+              <a:rPr dirty="0" err="1">
+                <a:latin typeface="Times New Roman" panose="02020603050405020304" pitchFamily="18" charset="0"/>
+                <a:cs typeface="Times New Roman" panose="02020603050405020304" pitchFamily="18" charset="0"/>
+              </a:rPr>
+              <a:t>μμές</a:t>
+            </a:r>
+            <a:r>
+              <a:rPr dirty="0">
+                <a:latin typeface="Times New Roman" panose="02020603050405020304" pitchFamily="18" charset="0"/>
+                <a:cs typeface="Times New Roman" panose="02020603050405020304" pitchFamily="18" charset="0"/>
+              </a:rPr>
+              <a:t> </a:t>
+            </a:r>
+            <a:r>
+              <a:rPr dirty="0" err="1">
+                <a:latin typeface="Times New Roman" panose="02020603050405020304" pitchFamily="18" charset="0"/>
+                <a:cs typeface="Times New Roman" panose="02020603050405020304" pitchFamily="18" charset="0"/>
+              </a:rPr>
+              <a:t>Κώδικ</a:t>
+            </a:r>
+            <a:r>
+              <a:rPr dirty="0">
+                <a:latin typeface="Times New Roman" panose="02020603050405020304" pitchFamily="18" charset="0"/>
+                <a:cs typeface="Times New Roman" panose="02020603050405020304" pitchFamily="18" charset="0"/>
+              </a:rPr>
+              <a:t>α</a:t>
             </a:r>
           </a:p>
           <a:p>
@@ -10337,7 +10398,18 @@
               </a:defRPr>
             </a:pPr>
             <a:r>
-              <a:t>⚙️ game_manager.gd: 406 Γραμμές (240-book MultiMesh, triangle puzzle logic, atmospheric tweens)</a:t>
+              <a:rPr dirty="0">
+                <a:latin typeface="Times New Roman" panose="02020603050405020304" pitchFamily="18" charset="0"/>
+                <a:cs typeface="Times New Roman" panose="02020603050405020304" pitchFamily="18" charset="0"/>
+              </a:rPr>
+              <a:t>🧠 </a:t>
+            </a:r>
+            <a:r>
+              <a:rPr dirty="0" err="1">
+                <a:latin typeface="Times New Roman" panose="02020603050405020304" pitchFamily="18" charset="0"/>
+                <a:cs typeface="Times New Roman" panose="02020603050405020304" pitchFamily="18" charset="0"/>
+              </a:rPr>
+              <a:t>game_manager.gd</a:t>
             </a:r>
             <a:endParaRPr dirty="0">
               <a:latin typeface="Times New Roman" panose="02020603050405020304" pitchFamily="18" charset="0"/>
@@ -20958,7 +21030,11 @@
               </a:defRPr>
             </a:pPr>
             <a:r>
-              <a:t>• Δυναμικό Στόχαστρο: Αυτόματη μετατροπή από + σε χρυσό ✋ κατά την εστίαση σε interactable.</a:t>
+              <a:rPr dirty="0">
+                <a:latin typeface="Times New Roman" panose="02020603050405020304" pitchFamily="18" charset="0"/>
+                <a:cs typeface="Times New Roman" panose="02020603050405020304" pitchFamily="18" charset="0"/>
+              </a:rPr>
+              <a:t>RayCast3D, Signals &amp; Adaptive Crosshair</a:t>
             </a:r>
           </a:p>
         </p:txBody>
@@ -21062,7 +21138,151 @@
               </a:defRPr>
             </a:pPr>
             <a:r>
-              <a:t>• Ακτίνα Ανίχνευσης: Μήκους 3.0 μέτρων από το κέντρο της κάμερας.</a:t>
+              <a:rPr dirty="0">
+                <a:latin typeface="Times New Roman" panose="02020603050405020304" pitchFamily="18" charset="0"/>
+                <a:cs typeface="Times New Roman" panose="02020603050405020304" pitchFamily="18" charset="0"/>
+              </a:rPr>
+              <a:t>• </a:t>
+            </a:r>
+            <a:r>
+              <a:rPr dirty="0" err="1">
+                <a:latin typeface="Times New Roman" panose="02020603050405020304" pitchFamily="18" charset="0"/>
+                <a:cs typeface="Times New Roman" panose="02020603050405020304" pitchFamily="18" charset="0"/>
+              </a:rPr>
+              <a:t>Ακτίν</a:t>
+            </a:r>
+            <a:r>
+              <a:rPr dirty="0">
+                <a:latin typeface="Times New Roman" panose="02020603050405020304" pitchFamily="18" charset="0"/>
+                <a:cs typeface="Times New Roman" panose="02020603050405020304" pitchFamily="18" charset="0"/>
+              </a:rPr>
+              <a:t>α </a:t>
+            </a:r>
+            <a:r>
+              <a:rPr dirty="0" err="1">
+                <a:latin typeface="Times New Roman" panose="02020603050405020304" pitchFamily="18" charset="0"/>
+                <a:cs typeface="Times New Roman" panose="02020603050405020304" pitchFamily="18" charset="0"/>
+              </a:rPr>
+              <a:t>Ανίχνευσης</a:t>
+            </a:r>
+            <a:r>
+              <a:rPr dirty="0">
+                <a:latin typeface="Times New Roman" panose="02020603050405020304" pitchFamily="18" charset="0"/>
+                <a:cs typeface="Times New Roman" panose="02020603050405020304" pitchFamily="18" charset="0"/>
+              </a:rPr>
+              <a:t>: </a:t>
+            </a:r>
+            <a:r>
+              <a:rPr dirty="0" err="1">
+                <a:latin typeface="Times New Roman" panose="02020603050405020304" pitchFamily="18" charset="0"/>
+                <a:cs typeface="Times New Roman" panose="02020603050405020304" pitchFamily="18" charset="0"/>
+              </a:rPr>
+              <a:t>Μήκους</a:t>
+            </a:r>
+            <a:r>
+              <a:rPr dirty="0">
+                <a:latin typeface="Times New Roman" panose="02020603050405020304" pitchFamily="18" charset="0"/>
+                <a:cs typeface="Times New Roman" panose="02020603050405020304" pitchFamily="18" charset="0"/>
+              </a:rPr>
+              <a:t> 2.5 </a:t>
+            </a:r>
+            <a:r>
+              <a:rPr dirty="0" err="1">
+                <a:latin typeface="Times New Roman" panose="02020603050405020304" pitchFamily="18" charset="0"/>
+                <a:cs typeface="Times New Roman" panose="02020603050405020304" pitchFamily="18" charset="0"/>
+              </a:rPr>
+              <a:t>μέτρων</a:t>
+            </a:r>
+            <a:r>
+              <a:rPr dirty="0">
+                <a:latin typeface="Times New Roman" panose="02020603050405020304" pitchFamily="18" charset="0"/>
+                <a:cs typeface="Times New Roman" panose="02020603050405020304" pitchFamily="18" charset="0"/>
+              </a:rPr>
+              <a:t> απ</a:t>
+            </a:r>
+            <a:r>
+              <a:rPr dirty="0" err="1">
+                <a:latin typeface="Times New Roman" panose="02020603050405020304" pitchFamily="18" charset="0"/>
+                <a:cs typeface="Times New Roman" panose="02020603050405020304" pitchFamily="18" charset="0"/>
+              </a:rPr>
+              <a:t>ό</a:t>
+            </a:r>
+            <a:r>
+              <a:rPr dirty="0">
+                <a:latin typeface="Times New Roman" panose="02020603050405020304" pitchFamily="18" charset="0"/>
+                <a:cs typeface="Times New Roman" panose="02020603050405020304" pitchFamily="18" charset="0"/>
+              </a:rPr>
+              <a:t> </a:t>
+            </a:r>
+            <a:r>
+              <a:rPr dirty="0" err="1">
+                <a:latin typeface="Times New Roman" panose="02020603050405020304" pitchFamily="18" charset="0"/>
+                <a:cs typeface="Times New Roman" panose="02020603050405020304" pitchFamily="18" charset="0"/>
+              </a:rPr>
+              <a:t>το</a:t>
+            </a:r>
+            <a:r>
+              <a:rPr dirty="0">
+                <a:latin typeface="Times New Roman" panose="02020603050405020304" pitchFamily="18" charset="0"/>
+                <a:cs typeface="Times New Roman" panose="02020603050405020304" pitchFamily="18" charset="0"/>
+              </a:rPr>
+              <a:t> </a:t>
+            </a:r>
+            <a:r>
+              <a:rPr dirty="0" err="1">
+                <a:latin typeface="Times New Roman" panose="02020603050405020304" pitchFamily="18" charset="0"/>
+                <a:cs typeface="Times New Roman" panose="02020603050405020304" pitchFamily="18" charset="0"/>
+              </a:rPr>
+              <a:t>κέντρο</a:t>
+            </a:r>
+            <a:r>
+              <a:rPr dirty="0">
+                <a:latin typeface="Times New Roman" panose="02020603050405020304" pitchFamily="18" charset="0"/>
+                <a:cs typeface="Times New Roman" panose="02020603050405020304" pitchFamily="18" charset="0"/>
+              </a:rPr>
+              <a:t> </a:t>
+            </a:r>
+            <a:r>
+              <a:rPr dirty="0" err="1">
+                <a:latin typeface="Times New Roman" panose="02020603050405020304" pitchFamily="18" charset="0"/>
+                <a:cs typeface="Times New Roman" panose="02020603050405020304" pitchFamily="18" charset="0"/>
+              </a:rPr>
+              <a:t>της</a:t>
+            </a:r>
+            <a:r>
+              <a:rPr dirty="0">
+                <a:latin typeface="Times New Roman" panose="02020603050405020304" pitchFamily="18" charset="0"/>
+                <a:cs typeface="Times New Roman" panose="02020603050405020304" pitchFamily="18" charset="0"/>
+              </a:rPr>
+              <a:t> </a:t>
+            </a:r>
+            <a:r>
+              <a:rPr dirty="0" err="1">
+                <a:latin typeface="Times New Roman" panose="02020603050405020304" pitchFamily="18" charset="0"/>
+                <a:cs typeface="Times New Roman" panose="02020603050405020304" pitchFamily="18" charset="0"/>
+              </a:rPr>
+              <a:t>κάμερ</a:t>
+            </a:r>
+            <a:r>
+              <a:rPr dirty="0">
+                <a:latin typeface="Times New Roman" panose="02020603050405020304" pitchFamily="18" charset="0"/>
+                <a:cs typeface="Times New Roman" panose="02020603050405020304" pitchFamily="18" charset="0"/>
+              </a:rPr>
+              <a:t>α</a:t>
+            </a:r>
+            <a:r>
+              <a:rPr dirty="0" err="1">
+                <a:latin typeface="Times New Roman" panose="02020603050405020304" pitchFamily="18" charset="0"/>
+                <a:cs typeface="Times New Roman" panose="02020603050405020304" pitchFamily="18" charset="0"/>
+              </a:rPr>
+              <a:t>ς</a:t>
+            </a:r>
+            <a:r>
+              <a:rPr dirty="0">
+                <a:latin typeface="Times New Roman" panose="02020603050405020304" pitchFamily="18" charset="0"/>
+                <a:cs typeface="Times New Roman" panose="02020603050405020304" pitchFamily="18" charset="0"/>
+              </a:rPr>
+              <a:t>.</a:t>
             </a:r>
           </a:p>
           <a:p>
@@ -25268,7 +25488,165 @@
               </a:defRPr>
             </a:pPr>
             <a:r>
-              <a:t>• Μη Λυμένη Αρχικοποίηση: Οι ράβδοι ξεκινούν στις γωνίες [0.0°, 180.0°, 60.0°] (μη λυμένη κατάσταση).</a:t>
+              <a:rPr dirty="0">
+                <a:latin typeface="Times New Roman" panose="02020603050405020304" pitchFamily="18" charset="0"/>
+                <a:cs typeface="Times New Roman" panose="02020603050405020304" pitchFamily="18" charset="0"/>
+              </a:rPr>
+              <a:t>• </a:t>
+            </a:r>
+            <a:r>
+              <a:rPr dirty="0" err="1">
+                <a:latin typeface="Times New Roman" panose="02020603050405020304" pitchFamily="18" charset="0"/>
+                <a:cs typeface="Times New Roman" panose="02020603050405020304" pitchFamily="18" charset="0"/>
+              </a:rPr>
+              <a:t>Τυχ</a:t>
+            </a:r>
+            <a:r>
+              <a:rPr dirty="0">
+                <a:latin typeface="Times New Roman" panose="02020603050405020304" pitchFamily="18" charset="0"/>
+                <a:cs typeface="Times New Roman" panose="02020603050405020304" pitchFamily="18" charset="0"/>
+              </a:rPr>
+              <a:t>α</a:t>
+            </a:r>
+            <a:r>
+              <a:rPr dirty="0" err="1">
+                <a:latin typeface="Times New Roman" panose="02020603050405020304" pitchFamily="18" charset="0"/>
+                <a:cs typeface="Times New Roman" panose="02020603050405020304" pitchFamily="18" charset="0"/>
+              </a:rPr>
+              <a:t>ίες</a:t>
+            </a:r>
+            <a:r>
+              <a:rPr dirty="0">
+                <a:latin typeface="Times New Roman" panose="02020603050405020304" pitchFamily="18" charset="0"/>
+                <a:cs typeface="Times New Roman" panose="02020603050405020304" pitchFamily="18" charset="0"/>
+              </a:rPr>
+              <a:t> </a:t>
+            </a:r>
+            <a:r>
+              <a:rPr dirty="0" err="1">
+                <a:latin typeface="Times New Roman" panose="02020603050405020304" pitchFamily="18" charset="0"/>
+                <a:cs typeface="Times New Roman" panose="02020603050405020304" pitchFamily="18" charset="0"/>
+              </a:rPr>
+              <a:t>Αρχικές</a:t>
+            </a:r>
+            <a:r>
+              <a:rPr dirty="0">
+                <a:latin typeface="Times New Roman" panose="02020603050405020304" pitchFamily="18" charset="0"/>
+                <a:cs typeface="Times New Roman" panose="02020603050405020304" pitchFamily="18" charset="0"/>
+              </a:rPr>
+              <a:t> </a:t>
+            </a:r>
+            <a:r>
+              <a:rPr dirty="0" err="1">
+                <a:latin typeface="Times New Roman" panose="02020603050405020304" pitchFamily="18" charset="0"/>
+                <a:cs typeface="Times New Roman" panose="02020603050405020304" pitchFamily="18" charset="0"/>
+              </a:rPr>
+              <a:t>Γωνίες</a:t>
+            </a:r>
+            <a:r>
+              <a:rPr dirty="0">
+                <a:latin typeface="Times New Roman" panose="02020603050405020304" pitchFamily="18" charset="0"/>
+                <a:cs typeface="Times New Roman" panose="02020603050405020304" pitchFamily="18" charset="0"/>
+              </a:rPr>
+              <a:t>: </a:t>
+            </a:r>
+            <a:r>
+              <a:rPr dirty="0" err="1">
+                <a:latin typeface="Times New Roman" panose="02020603050405020304" pitchFamily="18" charset="0"/>
+                <a:cs typeface="Times New Roman" panose="02020603050405020304" pitchFamily="18" charset="0"/>
+              </a:rPr>
+              <a:t>Οι</a:t>
+            </a:r>
+            <a:r>
+              <a:rPr dirty="0">
+                <a:latin typeface="Times New Roman" panose="02020603050405020304" pitchFamily="18" charset="0"/>
+                <a:cs typeface="Times New Roman" panose="02020603050405020304" pitchFamily="18" charset="0"/>
+              </a:rPr>
+              <a:t> </a:t>
+            </a:r>
+            <a:r>
+              <a:rPr dirty="0" err="1">
+                <a:latin typeface="Times New Roman" panose="02020603050405020304" pitchFamily="18" charset="0"/>
+                <a:cs typeface="Times New Roman" panose="02020603050405020304" pitchFamily="18" charset="0"/>
+              </a:rPr>
+              <a:t>ρά</a:t>
+            </a:r>
+            <a:r>
+              <a:rPr dirty="0">
+                <a:latin typeface="Times New Roman" panose="02020603050405020304" pitchFamily="18" charset="0"/>
+                <a:cs typeface="Times New Roman" panose="02020603050405020304" pitchFamily="18" charset="0"/>
+              </a:rPr>
+              <a:t>β</a:t>
+            </a:r>
+            <a:r>
+              <a:rPr dirty="0" err="1">
+                <a:latin typeface="Times New Roman" panose="02020603050405020304" pitchFamily="18" charset="0"/>
+                <a:cs typeface="Times New Roman" panose="02020603050405020304" pitchFamily="18" charset="0"/>
+              </a:rPr>
+              <a:t>δοι</a:t>
+            </a:r>
+            <a:r>
+              <a:rPr dirty="0">
+                <a:latin typeface="Times New Roman" panose="02020603050405020304" pitchFamily="18" charset="0"/>
+                <a:cs typeface="Times New Roman" panose="02020603050405020304" pitchFamily="18" charset="0"/>
+              </a:rPr>
+              <a:t> </a:t>
+            </a:r>
+            <a:r>
+              <a:rPr dirty="0" err="1">
+                <a:latin typeface="Times New Roman" panose="02020603050405020304" pitchFamily="18" charset="0"/>
+                <a:cs typeface="Times New Roman" panose="02020603050405020304" pitchFamily="18" charset="0"/>
+              </a:rPr>
+              <a:t>ξεκινούν</a:t>
+            </a:r>
+            <a:r>
+              <a:rPr dirty="0">
+                <a:latin typeface="Times New Roman" panose="02020603050405020304" pitchFamily="18" charset="0"/>
+                <a:cs typeface="Times New Roman" panose="02020603050405020304" pitchFamily="18" charset="0"/>
+              </a:rPr>
+              <a:t> α</a:t>
+            </a:r>
+            <a:r>
+              <a:rPr dirty="0" err="1">
+                <a:latin typeface="Times New Roman" panose="02020603050405020304" pitchFamily="18" charset="0"/>
+                <a:cs typeface="Times New Roman" panose="02020603050405020304" pitchFamily="18" charset="0"/>
+              </a:rPr>
+              <a:t>ν</a:t>
+            </a:r>
+            <a:r>
+              <a:rPr dirty="0">
+                <a:latin typeface="Times New Roman" panose="02020603050405020304" pitchFamily="18" charset="0"/>
+                <a:cs typeface="Times New Roman" panose="02020603050405020304" pitchFamily="18" charset="0"/>
+              </a:rPr>
+              <a:t>α</a:t>
+            </a:r>
+            <a:r>
+              <a:rPr dirty="0" err="1">
+                <a:latin typeface="Times New Roman" panose="02020603050405020304" pitchFamily="18" charset="0"/>
+                <a:cs typeface="Times New Roman" panose="02020603050405020304" pitchFamily="18" charset="0"/>
+              </a:rPr>
+              <a:t>κ</a:t>
+            </a:r>
+            <a:r>
+              <a:rPr dirty="0">
+                <a:latin typeface="Times New Roman" panose="02020603050405020304" pitchFamily="18" charset="0"/>
+                <a:cs typeface="Times New Roman" panose="02020603050405020304" pitchFamily="18" charset="0"/>
+              </a:rPr>
+              <a:t>α</a:t>
+            </a:r>
+            <a:r>
+              <a:rPr dirty="0" err="1">
+                <a:latin typeface="Times New Roman" panose="02020603050405020304" pitchFamily="18" charset="0"/>
+                <a:cs typeface="Times New Roman" panose="02020603050405020304" pitchFamily="18" charset="0"/>
+              </a:rPr>
+              <a:t>τεμένες</a:t>
+            </a:r>
+            <a:r>
+              <a:rPr dirty="0">
+                <a:latin typeface="Times New Roman" panose="02020603050405020304" pitchFamily="18" charset="0"/>
+                <a:cs typeface="Times New Roman" panose="02020603050405020304" pitchFamily="18" charset="0"/>
+              </a:rPr>
+              <a:t> (120°, 0°, 60°).</a:t>
             </a:r>
           </a:p>
           <a:p>

</xml_diff>

<commit_message>
docs(presentation): update presentation with real metrics, raycast 3.0m, hand icon, and screenshots
</commit_message>
<xml_diff>
--- a/Deliverables/The_Secret_Library_Presentation.pptx
+++ b/Deliverables/The_Secret_Library_Presentation.pptx
@@ -449,7 +449,7 @@
           <a:lstStyle/>
           <a:p>
             <a:r>
-              <a:t>Ιδιαίτερη έμφαση δόθηκε στη βελτιστοποίηση: μηδενικό μέγεθος assets μέσω procedural primitives, batching υλικών για χαμηλά draw calls, και Jolt Physics για ταχύτατες συγκρούσεις.</a:t>
+              <a:t>Ιδιαίτερη έμφαση δόθηκε στη βελτιστοποίηση: μηδενικό μέγεθος assets μέσω procedural primitives, διαμοιρασμός κοινών PBR υλικών για χαμηλά draw calls, και Jolt Physics για ταχύτατες συγκρούσεις.</a:t>
             </a:r>
           </a:p>
         </p:txBody>
@@ -1079,7 +1079,7 @@
           <a:lstStyle/>
           <a:p>
             <a:r>
-              <a:t>Η ανίχνευση γίνεται μέσω RayCast3D. Όταν ο παίκτης κοιτάζει κάποιο αντικείμενο, το στόχαστρο μετατρέπεται δυναμικά σε χέρι 🫱 και εμφανίζεται το κατάλληλο μήνυμα προτροπής.</a:t>
+              <a:t>Η ανίχνευση γίνεται μέσω RayCast3D. Όταν ο παίκτης κοιτάζει κάποιο αντικείμενο, το στόχαστρο μετατρέπεται δυναμικά σε χέρι ✋ και εμφανίζεται το κατάλληλο μήνυμα προτροπής.</a:t>
             </a:r>
           </a:p>
         </p:txBody>
@@ -5078,7 +5078,7 @@
         <p:spPr>
           <a:xfrm>
             <a:off x="731520" y="1691640"/>
-            <a:ext cx="5166360" cy="4663440"/>
+            <a:ext cx="5852160" cy="2240280"/>
           </a:xfrm>
           <a:prstGeom prst="roundRect">
             <a:avLst/>
@@ -5203,7 +5203,7 @@
               <a:spcAft>
                 <a:spcPts val="900"/>
               </a:spcAft>
-              <a:defRPr sz="1300">
+              <a:defRPr sz="1200">
                 <a:solidFill>
                   <a:srgbClr val="DCE2EB"/>
                 </a:solidFill>
@@ -5404,7 +5404,7 @@
               <a:spcAft>
                 <a:spcPts val="900"/>
               </a:spcAft>
-              <a:defRPr sz="1300">
+              <a:defRPr sz="1200">
                 <a:solidFill>
                   <a:srgbClr val="DCE2EB"/>
                 </a:solidFill>
@@ -5479,7 +5479,7 @@
               <a:spcAft>
                 <a:spcPts val="900"/>
               </a:spcAft>
-              <a:defRPr sz="1300">
+              <a:defRPr sz="1200">
                 <a:solidFill>
                   <a:srgbClr val="DCE2EB"/>
                 </a:solidFill>
@@ -5680,7 +5680,7 @@
               <a:spcAft>
                 <a:spcPts val="900"/>
               </a:spcAft>
-              <a:defRPr sz="1300">
+              <a:defRPr sz="1200">
                 <a:solidFill>
                   <a:srgbClr val="DCE2EB"/>
                 </a:solidFill>
@@ -5886,8 +5886,8 @@
         </p:nvSpPr>
         <p:spPr>
           <a:xfrm>
-            <a:off x="6263640" y="1691640"/>
-            <a:ext cx="5166360" cy="4663440"/>
+            <a:off x="731520" y="4069080"/>
+            <a:ext cx="5852160" cy="2286000"/>
           </a:xfrm>
           <a:prstGeom prst="roundRect">
             <a:avLst/>
@@ -5970,7 +5970,7 @@
               <a:spcAft>
                 <a:spcPts val="900"/>
               </a:spcAft>
-              <a:defRPr sz="1300">
+              <a:defRPr sz="1200">
                 <a:solidFill>
                   <a:srgbClr val="DCE2EB"/>
                 </a:solidFill>
@@ -6129,7 +6129,7 @@
               <a:spcAft>
                 <a:spcPts val="900"/>
               </a:spcAft>
-              <a:defRPr sz="1300">
+              <a:defRPr sz="1200">
                 <a:solidFill>
                   <a:srgbClr val="DCE2EB"/>
                 </a:solidFill>
@@ -6288,7 +6288,7 @@
               <a:spcAft>
                 <a:spcPts val="900"/>
               </a:spcAft>
-              <a:defRPr sz="1300">
+              <a:defRPr sz="1200">
                 <a:solidFill>
                   <a:srgbClr val="DCE2EB"/>
                 </a:solidFill>
@@ -6475,7 +6475,7 @@
               <a:spcAft>
                 <a:spcPts val="900"/>
               </a:spcAft>
-              <a:defRPr sz="1300">
+              <a:defRPr sz="1200">
                 <a:solidFill>
                   <a:srgbClr val="DCE2EB"/>
                 </a:solidFill>
@@ -6655,6 +6655,65 @@
                 <a:cs typeface="Times New Roman" panose="02020603050405020304" pitchFamily="18" charset="0"/>
               </a:rPr>
               <a:t>.</a:t>
+            </a:r>
+          </a:p>
+        </p:txBody>
+      </p:sp>
+      <p:pic>
+        <p:nvPicPr>
+          <p:cNvPr id="8" name="Picture 7" descr="image4.png"/>
+          <p:cNvPicPr>
+            <a:picLocks noChangeAspect="1"/>
+          </p:cNvPicPr>
+          <p:nvPr/>
+        </p:nvPicPr>
+        <p:blipFill>
+          <a:blip r:embed="rId3"/>
+          <a:stretch>
+            <a:fillRect/>
+          </a:stretch>
+        </p:blipFill>
+        <p:spPr>
+          <a:xfrm>
+            <a:off x="6858000" y="1691640"/>
+            <a:ext cx="4572000" cy="4023360"/>
+          </a:xfrm>
+          <a:prstGeom prst="rect">
+            <a:avLst/>
+          </a:prstGeom>
+        </p:spPr>
+      </p:pic>
+      <p:sp>
+        <p:nvSpPr>
+          <p:cNvPr id="9" name="TextBox 8"/>
+          <p:cNvSpPr txBox="1"/>
+          <p:nvPr/>
+        </p:nvSpPr>
+        <p:spPr>
+          <a:xfrm>
+            <a:off x="6858000" y="5779008"/>
+            <a:ext cx="4572000" cy="502920"/>
+          </a:xfrm>
+          <a:prstGeom prst="rect">
+            <a:avLst/>
+          </a:prstGeom>
+          <a:noFill/>
+        </p:spPr>
+        <p:txBody>
+          <a:bodyPr wrap="square">
+            <a:spAutoFit/>
+          </a:bodyPr>
+          <a:lstStyle/>
+          <a:p>
+            <a:pPr algn="ctr">
+              <a:defRPr sz="1100">
+                <a:solidFill>
+                  <a:srgbClr val="D4AF37"/>
+                </a:solidFill>
+              </a:defRPr>
+            </a:pPr>
+            <a:r>
+              <a:t>📷 In-Game: Το ξεκλείδωμα θυρεού &amp; η μυστική πόρτα</a:t>
             </a:r>
           </a:p>
         </p:txBody>
@@ -7081,220 +7140,46 @@
           <a:lstStyle/>
           <a:p>
             <a:pPr algn="ctr">
-              <a:defRPr sz="1600" b="1">
+              <a:defRPr sz="1700" b="1">
                 <a:solidFill>
                   <a:srgbClr val="D4AF37"/>
                 </a:solidFill>
               </a:defRPr>
             </a:pPr>
             <a:r>
-              <a:rPr dirty="0">
-                <a:latin typeface="Times New Roman" panose="02020603050405020304" pitchFamily="18" charset="0"/>
-                <a:cs typeface="Times New Roman" panose="02020603050405020304" pitchFamily="18" charset="0"/>
-              </a:rPr>
               <a:t>📦 Asset &amp; Geometry</a:t>
             </a:r>
           </a:p>
           <a:p>
             <a:pPr>
-              <a:spcAft>
-                <a:spcPts val="1200"/>
-              </a:spcAft>
-              <a:defRPr sz="1400" b="1">
-                <a:solidFill>
-                  <a:srgbClr val="FFFFFF"/>
-                </a:solidFill>
-              </a:defRPr>
+              <a:defRPr sz="1500"/>
             </a:pPr>
             <a:r>
-              <a:rPr dirty="0">
-                <a:latin typeface="Times New Roman" panose="02020603050405020304" pitchFamily="18" charset="0"/>
-                <a:cs typeface="Times New Roman" panose="02020603050405020304" pitchFamily="18" charset="0"/>
-              </a:rPr>
               <a:t>Procedural Primitives</a:t>
             </a:r>
           </a:p>
           <a:p>
-            <a:pPr algn="just">
-              <a:spcAft>
-                <a:spcPts val="800"/>
-              </a:spcAft>
-              <a:defRPr sz="1200">
-                <a:solidFill>
-                  <a:srgbClr val="DCE2EB"/>
-                </a:solidFill>
-              </a:defRPr>
+            <a:pPr>
+              <a:defRPr sz="1300"/>
             </a:pPr>
             <a:r>
-              <a:rPr dirty="0">
-                <a:latin typeface="Times New Roman" panose="02020603050405020304" pitchFamily="18" charset="0"/>
-                <a:cs typeface="Times New Roman" panose="02020603050405020304" pitchFamily="18" charset="0"/>
-              </a:rPr>
-              <a:t>• </a:t>
-            </a:r>
-            <a:r>
-              <a:rPr dirty="0" err="1">
-                <a:latin typeface="Times New Roman" panose="02020603050405020304" pitchFamily="18" charset="0"/>
-                <a:cs typeface="Times New Roman" panose="02020603050405020304" pitchFamily="18" charset="0"/>
-              </a:rPr>
-              <a:t>Μηδενικό</a:t>
-            </a:r>
-            <a:r>
-              <a:rPr dirty="0">
-                <a:latin typeface="Times New Roman" panose="02020603050405020304" pitchFamily="18" charset="0"/>
-                <a:cs typeface="Times New Roman" panose="02020603050405020304" pitchFamily="18" charset="0"/>
-              </a:rPr>
-              <a:t> </a:t>
-            </a:r>
-            <a:r>
-              <a:rPr dirty="0" err="1">
-                <a:latin typeface="Times New Roman" panose="02020603050405020304" pitchFamily="18" charset="0"/>
-                <a:cs typeface="Times New Roman" panose="02020603050405020304" pitchFamily="18" charset="0"/>
-              </a:rPr>
-              <a:t>μέγεθος</a:t>
-            </a:r>
-            <a:r>
-              <a:rPr dirty="0">
-                <a:latin typeface="Times New Roman" panose="02020603050405020304" pitchFamily="18" charset="0"/>
-                <a:cs typeface="Times New Roman" panose="02020603050405020304" pitchFamily="18" charset="0"/>
-              </a:rPr>
-              <a:t> </a:t>
-            </a:r>
-            <a:r>
-              <a:rPr dirty="0" err="1">
-                <a:latin typeface="Times New Roman" panose="02020603050405020304" pitchFamily="18" charset="0"/>
-                <a:cs typeface="Times New Roman" panose="02020603050405020304" pitchFamily="18" charset="0"/>
-              </a:rPr>
-              <a:t>εξωτερικών</a:t>
-            </a:r>
-            <a:r>
-              <a:rPr dirty="0">
-                <a:latin typeface="Times New Roman" panose="02020603050405020304" pitchFamily="18" charset="0"/>
-                <a:cs typeface="Times New Roman" panose="02020603050405020304" pitchFamily="18" charset="0"/>
-              </a:rPr>
-              <a:t> 3D α</a:t>
-            </a:r>
-            <a:r>
-              <a:rPr dirty="0" err="1">
-                <a:latin typeface="Times New Roman" panose="02020603050405020304" pitchFamily="18" charset="0"/>
-                <a:cs typeface="Times New Roman" panose="02020603050405020304" pitchFamily="18" charset="0"/>
-              </a:rPr>
-              <a:t>ρχείων</a:t>
-            </a:r>
-            <a:r>
-              <a:rPr dirty="0">
-                <a:latin typeface="Times New Roman" panose="02020603050405020304" pitchFamily="18" charset="0"/>
-                <a:cs typeface="Times New Roman" panose="02020603050405020304" pitchFamily="18" charset="0"/>
-              </a:rPr>
-              <a:t> (.obj/.</a:t>
-            </a:r>
-            <a:r>
-              <a:rPr dirty="0" err="1">
-                <a:latin typeface="Times New Roman" panose="02020603050405020304" pitchFamily="18" charset="0"/>
-                <a:cs typeface="Times New Roman" panose="02020603050405020304" pitchFamily="18" charset="0"/>
-              </a:rPr>
-              <a:t>gltf</a:t>
-            </a:r>
-            <a:r>
-              <a:rPr dirty="0">
-                <a:latin typeface="Times New Roman" panose="02020603050405020304" pitchFamily="18" charset="0"/>
-                <a:cs typeface="Times New Roman" panose="02020603050405020304" pitchFamily="18" charset="0"/>
-              </a:rPr>
-              <a:t>)</a:t>
-            </a:r>
-          </a:p>
-          <a:p>
-            <a:pPr algn="just">
-              <a:spcAft>
-                <a:spcPts val="800"/>
-              </a:spcAft>
-              <a:defRPr sz="1200">
-                <a:solidFill>
-                  <a:srgbClr val="DCE2EB"/>
-                </a:solidFill>
-              </a:defRPr>
+              <a:t>• Μηδενικό μέγεθος εξωτερικών 3D αρχείων (.obj/.gltf)</a:t>
+            </a:r>
+          </a:p>
+          <a:p>
+            <a:pPr>
+              <a:defRPr sz="1300"/>
             </a:pPr>
             <a:r>
-              <a:rPr dirty="0">
-                <a:latin typeface="Times New Roman" panose="02020603050405020304" pitchFamily="18" charset="0"/>
-                <a:cs typeface="Times New Roman" panose="02020603050405020304" pitchFamily="18" charset="0"/>
-              </a:rPr>
-              <a:t>• </a:t>
-            </a:r>
-            <a:r>
-              <a:rPr dirty="0" err="1">
-                <a:latin typeface="Times New Roman" panose="02020603050405020304" pitchFamily="18" charset="0"/>
-                <a:cs typeface="Times New Roman" panose="02020603050405020304" pitchFamily="18" charset="0"/>
-              </a:rPr>
-              <a:t>Χρήση</a:t>
-            </a:r>
-            <a:r>
-              <a:rPr dirty="0">
-                <a:latin typeface="Times New Roman" panose="02020603050405020304" pitchFamily="18" charset="0"/>
-                <a:cs typeface="Times New Roman" panose="02020603050405020304" pitchFamily="18" charset="0"/>
-              </a:rPr>
-              <a:t> native Box/Cylinder/Sphere meshes</a:t>
-            </a:r>
-          </a:p>
-          <a:p>
-            <a:pPr algn="just">
-              <a:spcAft>
-                <a:spcPts val="800"/>
-              </a:spcAft>
-              <a:defRPr sz="1200">
-                <a:solidFill>
-                  <a:srgbClr val="DCE2EB"/>
-                </a:solidFill>
-              </a:defRPr>
+              <a:t>• Χρήση native Box/Cylinder/Sphere meshes (20.892 τρίγωνα)</a:t>
+            </a:r>
+          </a:p>
+          <a:p>
+            <a:pPr>
+              <a:defRPr sz="1300"/>
             </a:pPr>
             <a:r>
-              <a:rPr dirty="0">
-                <a:latin typeface="Times New Roman" panose="02020603050405020304" pitchFamily="18" charset="0"/>
-                <a:cs typeface="Times New Roman" panose="02020603050405020304" pitchFamily="18" charset="0"/>
-              </a:rPr>
-              <a:t>• </a:t>
-            </a:r>
-            <a:r>
-              <a:rPr dirty="0" err="1">
-                <a:latin typeface="Times New Roman" panose="02020603050405020304" pitchFamily="18" charset="0"/>
-                <a:cs typeface="Times New Roman" panose="02020603050405020304" pitchFamily="18" charset="0"/>
-              </a:rPr>
-              <a:t>Άμεση</a:t>
-            </a:r>
-            <a:r>
-              <a:rPr dirty="0">
-                <a:latin typeface="Times New Roman" panose="02020603050405020304" pitchFamily="18" charset="0"/>
-                <a:cs typeface="Times New Roman" panose="02020603050405020304" pitchFamily="18" charset="0"/>
-              </a:rPr>
-              <a:t> </a:t>
-            </a:r>
-            <a:r>
-              <a:rPr dirty="0" err="1">
-                <a:latin typeface="Times New Roman" panose="02020603050405020304" pitchFamily="18" charset="0"/>
-                <a:cs typeface="Times New Roman" panose="02020603050405020304" pitchFamily="18" charset="0"/>
-              </a:rPr>
-              <a:t>φόρτωση</a:t>
-            </a:r>
-            <a:r>
-              <a:rPr dirty="0">
-                <a:latin typeface="Times New Roman" panose="02020603050405020304" pitchFamily="18" charset="0"/>
-                <a:cs typeface="Times New Roman" panose="02020603050405020304" pitchFamily="18" charset="0"/>
-              </a:rPr>
-              <a:t> </a:t>
-            </a:r>
-            <a:r>
-              <a:rPr dirty="0" err="1">
-                <a:latin typeface="Times New Roman" panose="02020603050405020304" pitchFamily="18" charset="0"/>
-                <a:cs typeface="Times New Roman" panose="02020603050405020304" pitchFamily="18" charset="0"/>
-              </a:rPr>
-              <a:t>στη</a:t>
-            </a:r>
-            <a:r>
-              <a:rPr dirty="0">
-                <a:latin typeface="Times New Roman" panose="02020603050405020304" pitchFamily="18" charset="0"/>
-                <a:cs typeface="Times New Roman" panose="02020603050405020304" pitchFamily="18" charset="0"/>
-              </a:rPr>
-              <a:t> VRAM</a:t>
+              <a:t>• Άμεση φόρτωση στη VRAM χωρίς I/O stalls</a:t>
             </a:r>
           </a:p>
         </p:txBody>
@@ -7341,262 +7226,46 @@
           <a:lstStyle/>
           <a:p>
             <a:pPr algn="ctr">
-              <a:defRPr sz="1600" b="1">
+              <a:defRPr sz="1700" b="1">
                 <a:solidFill>
                   <a:srgbClr val="4ECDC4"/>
                 </a:solidFill>
               </a:defRPr>
             </a:pPr>
             <a:r>
-              <a:rPr dirty="0">
-                <a:latin typeface="Times New Roman" panose="02020603050405020304" pitchFamily="18" charset="0"/>
-                <a:cs typeface="Times New Roman" panose="02020603050405020304" pitchFamily="18" charset="0"/>
-              </a:rPr>
               <a:t>🎨 Rendering &amp; Draw Calls</a:t>
             </a:r>
           </a:p>
           <a:p>
             <a:pPr>
-              <a:spcAft>
-                <a:spcPts val="1200"/>
-              </a:spcAft>
-              <a:defRPr sz="1400" b="1">
-                <a:solidFill>
-                  <a:srgbClr val="FFFFFF"/>
-                </a:solidFill>
-              </a:defRPr>
+              <a:defRPr sz="1500"/>
             </a:pPr>
             <a:r>
-              <a:rPr dirty="0">
-                <a:latin typeface="Times New Roman" panose="02020603050405020304" pitchFamily="18" charset="0"/>
-                <a:cs typeface="Times New Roman" panose="02020603050405020304" pitchFamily="18" charset="0"/>
-              </a:rPr>
-              <a:t>PBR Material Batching</a:t>
-            </a:r>
-          </a:p>
-          <a:p>
-            <a:pPr algn="just">
-              <a:spcAft>
-                <a:spcPts val="800"/>
-              </a:spcAft>
-              <a:defRPr sz="1200">
-                <a:solidFill>
-                  <a:srgbClr val="DCE2EB"/>
-                </a:solidFill>
-              </a:defRPr>
+              <a:t>Material Sharing &amp; State Optimization</a:t>
+            </a:r>
+          </a:p>
+          <a:p>
+            <a:pPr>
+              <a:defRPr sz="1300"/>
             </a:pPr>
             <a:r>
-              <a:rPr dirty="0">
-                <a:latin typeface="Times New Roman" panose="02020603050405020304" pitchFamily="18" charset="0"/>
-                <a:cs typeface="Times New Roman" panose="02020603050405020304" pitchFamily="18" charset="0"/>
-              </a:rPr>
-              <a:t>• </a:t>
-            </a:r>
-            <a:r>
-              <a:rPr dirty="0" err="1">
-                <a:latin typeface="Times New Roman" panose="02020603050405020304" pitchFamily="18" charset="0"/>
-                <a:cs typeface="Times New Roman" panose="02020603050405020304" pitchFamily="18" charset="0"/>
-              </a:rPr>
-              <a:t>Ε</a:t>
-            </a:r>
-            <a:r>
-              <a:rPr dirty="0">
-                <a:latin typeface="Times New Roman" panose="02020603050405020304" pitchFamily="18" charset="0"/>
-                <a:cs typeface="Times New Roman" panose="02020603050405020304" pitchFamily="18" charset="0"/>
-              </a:rPr>
-              <a:t>πα</a:t>
-            </a:r>
-            <a:r>
-              <a:rPr dirty="0" err="1">
-                <a:latin typeface="Times New Roman" panose="02020603050405020304" pitchFamily="18" charset="0"/>
-                <a:cs typeface="Times New Roman" panose="02020603050405020304" pitchFamily="18" charset="0"/>
-              </a:rPr>
-              <a:t>ν</a:t>
-            </a:r>
-            <a:r>
-              <a:rPr dirty="0">
-                <a:latin typeface="Times New Roman" panose="02020603050405020304" pitchFamily="18" charset="0"/>
-                <a:cs typeface="Times New Roman" panose="02020603050405020304" pitchFamily="18" charset="0"/>
-              </a:rPr>
-              <a:t>α</a:t>
-            </a:r>
-            <a:r>
-              <a:rPr dirty="0" err="1">
-                <a:latin typeface="Times New Roman" panose="02020603050405020304" pitchFamily="18" charset="0"/>
-                <a:cs typeface="Times New Roman" panose="02020603050405020304" pitchFamily="18" charset="0"/>
-              </a:rPr>
-              <a:t>χρησιμο</a:t>
-            </a:r>
-            <a:r>
-              <a:rPr dirty="0">
-                <a:latin typeface="Times New Roman" panose="02020603050405020304" pitchFamily="18" charset="0"/>
-                <a:cs typeface="Times New Roman" panose="02020603050405020304" pitchFamily="18" charset="0"/>
-              </a:rPr>
-              <a:t>π</a:t>
-            </a:r>
-            <a:r>
-              <a:rPr dirty="0" err="1">
-                <a:latin typeface="Times New Roman" panose="02020603050405020304" pitchFamily="18" charset="0"/>
-                <a:cs typeface="Times New Roman" panose="02020603050405020304" pitchFamily="18" charset="0"/>
-              </a:rPr>
-              <a:t>οίηση</a:t>
-            </a:r>
-            <a:r>
-              <a:rPr dirty="0">
-                <a:latin typeface="Times New Roman" panose="02020603050405020304" pitchFamily="18" charset="0"/>
-                <a:cs typeface="Times New Roman" panose="02020603050405020304" pitchFamily="18" charset="0"/>
-              </a:rPr>
-              <a:t> StandardMaterial3D</a:t>
-            </a:r>
-          </a:p>
-          <a:p>
-            <a:pPr algn="just">
-              <a:spcAft>
-                <a:spcPts val="800"/>
-              </a:spcAft>
-              <a:defRPr sz="1200">
-                <a:solidFill>
-                  <a:srgbClr val="DCE2EB"/>
-                </a:solidFill>
-              </a:defRPr>
+              <a:t>• Επαναχρησιμοποίηση StandardMaterial3D (κοινό ξύλο/μέταλλο)</a:t>
+            </a:r>
+          </a:p>
+          <a:p>
+            <a:pPr>
+              <a:defRPr sz="1300"/>
             </a:pPr>
             <a:r>
-              <a:rPr dirty="0">
-                <a:latin typeface="Times New Roman" panose="02020603050405020304" pitchFamily="18" charset="0"/>
-                <a:cs typeface="Times New Roman" panose="02020603050405020304" pitchFamily="18" charset="0"/>
-              </a:rPr>
-              <a:t>• </a:t>
-            </a:r>
-            <a:r>
-              <a:rPr dirty="0" err="1">
-                <a:latin typeface="Times New Roman" panose="02020603050405020304" pitchFamily="18" charset="0"/>
-                <a:cs typeface="Times New Roman" panose="02020603050405020304" pitchFamily="18" charset="0"/>
-              </a:rPr>
-              <a:t>Ελ</a:t>
-            </a:r>
-            <a:r>
-              <a:rPr dirty="0">
-                <a:latin typeface="Times New Roman" panose="02020603050405020304" pitchFamily="18" charset="0"/>
-                <a:cs typeface="Times New Roman" panose="02020603050405020304" pitchFamily="18" charset="0"/>
-              </a:rPr>
-              <a:t>α</a:t>
-            </a:r>
-            <a:r>
-              <a:rPr dirty="0" err="1">
-                <a:latin typeface="Times New Roman" panose="02020603050405020304" pitchFamily="18" charset="0"/>
-                <a:cs typeface="Times New Roman" panose="02020603050405020304" pitchFamily="18" charset="0"/>
-              </a:rPr>
-              <a:t>χιστο</a:t>
-            </a:r>
-            <a:r>
-              <a:rPr dirty="0">
-                <a:latin typeface="Times New Roman" panose="02020603050405020304" pitchFamily="18" charset="0"/>
-                <a:cs typeface="Times New Roman" panose="02020603050405020304" pitchFamily="18" charset="0"/>
-              </a:rPr>
-              <a:t>π</a:t>
-            </a:r>
-            <a:r>
-              <a:rPr dirty="0" err="1">
-                <a:latin typeface="Times New Roman" panose="02020603050405020304" pitchFamily="18" charset="0"/>
-                <a:cs typeface="Times New Roman" panose="02020603050405020304" pitchFamily="18" charset="0"/>
-              </a:rPr>
-              <a:t>οίηση</a:t>
-            </a:r>
-            <a:r>
-              <a:rPr dirty="0">
-                <a:latin typeface="Times New Roman" panose="02020603050405020304" pitchFamily="18" charset="0"/>
-                <a:cs typeface="Times New Roman" panose="02020603050405020304" pitchFamily="18" charset="0"/>
-              </a:rPr>
-              <a:t> shader program swaps</a:t>
-            </a:r>
-          </a:p>
-          <a:p>
-            <a:pPr algn="just">
-              <a:spcAft>
-                <a:spcPts val="800"/>
-              </a:spcAft>
-              <a:defRPr sz="1200">
-                <a:solidFill>
-                  <a:srgbClr val="DCE2EB"/>
-                </a:solidFill>
-              </a:defRPr>
+              <a:t>• 68 Draw Calls, 89 Αντικείμενα (-55% έναντι naive 150 DC)</a:t>
+            </a:r>
+          </a:p>
+          <a:p>
+            <a:pPr>
+              <a:defRPr sz="1300"/>
             </a:pPr>
             <a:r>
-              <a:rPr dirty="0">
-                <a:latin typeface="Times New Roman" panose="02020603050405020304" pitchFamily="18" charset="0"/>
-                <a:cs typeface="Times New Roman" panose="02020603050405020304" pitchFamily="18" charset="0"/>
-              </a:rPr>
-              <a:t>• </a:t>
-            </a:r>
-            <a:r>
-              <a:rPr dirty="0" err="1">
-                <a:latin typeface="Times New Roman" panose="02020603050405020304" pitchFamily="18" charset="0"/>
-                <a:cs typeface="Times New Roman" panose="02020603050405020304" pitchFamily="18" charset="0"/>
-              </a:rPr>
-              <a:t>Στ</a:t>
-            </a:r>
-            <a:r>
-              <a:rPr dirty="0">
-                <a:latin typeface="Times New Roman" panose="02020603050405020304" pitchFamily="18" charset="0"/>
-                <a:cs typeface="Times New Roman" panose="02020603050405020304" pitchFamily="18" charset="0"/>
-              </a:rPr>
-              <a:t>α</a:t>
-            </a:r>
-            <a:r>
-              <a:rPr dirty="0" err="1">
-                <a:latin typeface="Times New Roman" panose="02020603050405020304" pitchFamily="18" charset="0"/>
-                <a:cs typeface="Times New Roman" panose="02020603050405020304" pitchFamily="18" charset="0"/>
-              </a:rPr>
-              <a:t>θερά</a:t>
-            </a:r>
-            <a:r>
-              <a:rPr dirty="0">
-                <a:latin typeface="Times New Roman" panose="02020603050405020304" pitchFamily="18" charset="0"/>
-                <a:cs typeface="Times New Roman" panose="02020603050405020304" pitchFamily="18" charset="0"/>
-              </a:rPr>
-              <a:t> 60+ FPS </a:t>
-            </a:r>
-            <a:r>
-              <a:rPr dirty="0" err="1">
-                <a:latin typeface="Times New Roman" panose="02020603050405020304" pitchFamily="18" charset="0"/>
-                <a:cs typeface="Times New Roman" panose="02020603050405020304" pitchFamily="18" charset="0"/>
-              </a:rPr>
-              <a:t>σε</a:t>
-            </a:r>
-            <a:r>
-              <a:rPr dirty="0">
-                <a:latin typeface="Times New Roman" panose="02020603050405020304" pitchFamily="18" charset="0"/>
-                <a:cs typeface="Times New Roman" panose="02020603050405020304" pitchFamily="18" charset="0"/>
-              </a:rPr>
-              <a:t> </a:t>
-            </a:r>
-            <a:r>
-              <a:rPr dirty="0" err="1">
-                <a:latin typeface="Times New Roman" panose="02020603050405020304" pitchFamily="18" charset="0"/>
-                <a:cs typeface="Times New Roman" panose="02020603050405020304" pitchFamily="18" charset="0"/>
-              </a:rPr>
-              <a:t>κάθε</a:t>
-            </a:r>
-            <a:r>
-              <a:rPr dirty="0">
-                <a:latin typeface="Times New Roman" panose="02020603050405020304" pitchFamily="18" charset="0"/>
-                <a:cs typeface="Times New Roman" panose="02020603050405020304" pitchFamily="18" charset="0"/>
-              </a:rPr>
-              <a:t> </a:t>
-            </a:r>
-            <a:r>
-              <a:rPr dirty="0" err="1">
-                <a:latin typeface="Times New Roman" panose="02020603050405020304" pitchFamily="18" charset="0"/>
-                <a:cs typeface="Times New Roman" panose="02020603050405020304" pitchFamily="18" charset="0"/>
-              </a:rPr>
-              <a:t>σύστημ</a:t>
-            </a:r>
-            <a:r>
-              <a:rPr dirty="0">
-                <a:latin typeface="Times New Roman" panose="02020603050405020304" pitchFamily="18" charset="0"/>
-                <a:cs typeface="Times New Roman" panose="02020603050405020304" pitchFamily="18" charset="0"/>
-              </a:rPr>
-              <a:t>α</a:t>
+              <a:t>• 108.5 FPS avg (χωρίς V-Sync) / 60 FPS (V-Sync)</a:t>
             </a:r>
           </a:p>
         </p:txBody>
@@ -10193,49 +9862,49 @@
                 <a:latin typeface="Times New Roman" panose="02020603050405020304" pitchFamily="18" charset="0"/>
                 <a:cs typeface="Times New Roman" panose="02020603050405020304" pitchFamily="18" charset="0"/>
               </a:rPr>
-              <a:t>180 </a:t>
-            </a:r>
-            <a:r>
-              <a:rPr dirty="0" err="1">
-                <a:latin typeface="Times New Roman" panose="02020603050405020304" pitchFamily="18" charset="0"/>
-                <a:cs typeface="Times New Roman" panose="02020603050405020304" pitchFamily="18" charset="0"/>
-              </a:rPr>
-              <a:t>Γρ</a:t>
-            </a:r>
-            <a:r>
-              <a:rPr dirty="0">
-                <a:latin typeface="Times New Roman" panose="02020603050405020304" pitchFamily="18" charset="0"/>
-                <a:cs typeface="Times New Roman" panose="02020603050405020304" pitchFamily="18" charset="0"/>
-              </a:rPr>
-              <a:t>α</a:t>
-            </a:r>
-            <a:r>
-              <a:rPr dirty="0" err="1">
-                <a:latin typeface="Times New Roman" panose="02020603050405020304" pitchFamily="18" charset="0"/>
-                <a:cs typeface="Times New Roman" panose="02020603050405020304" pitchFamily="18" charset="0"/>
-              </a:rPr>
-              <a:t>μμές</a:t>
-            </a:r>
-            <a:r>
-              <a:rPr dirty="0">
-                <a:latin typeface="Times New Roman" panose="02020603050405020304" pitchFamily="18" charset="0"/>
-                <a:cs typeface="Times New Roman" panose="02020603050405020304" pitchFamily="18" charset="0"/>
-              </a:rPr>
-              <a:t> </a:t>
-            </a:r>
-            <a:r>
-              <a:rPr dirty="0" err="1">
-                <a:latin typeface="Times New Roman" panose="02020603050405020304" pitchFamily="18" charset="0"/>
-                <a:cs typeface="Times New Roman" panose="02020603050405020304" pitchFamily="18" charset="0"/>
-              </a:rPr>
-              <a:t>Κώδικ</a:t>
-            </a:r>
-            <a:r>
-              <a:rPr dirty="0">
-                <a:latin typeface="Times New Roman" panose="02020603050405020304" pitchFamily="18" charset="0"/>
-                <a:cs typeface="Times New Roman" panose="02020603050405020304" pitchFamily="18" charset="0"/>
-              </a:rPr>
-              <a:t>α</a:t>
+              <a:t>266 Γραμμές Κώδικα</a:t>
+            </a:r>
+            <a:r>
+              <a:rPr dirty="0" err="1">
+                <a:latin typeface="Times New Roman" panose="02020603050405020304" pitchFamily="18" charset="0"/>
+                <a:cs typeface="Times New Roman" panose="02020603050405020304" pitchFamily="18" charset="0"/>
+              </a:rPr>
+              <a:t/>
+            </a:r>
+            <a:r>
+              <a:rPr dirty="0">
+                <a:latin typeface="Times New Roman" panose="02020603050405020304" pitchFamily="18" charset="0"/>
+                <a:cs typeface="Times New Roman" panose="02020603050405020304" pitchFamily="18" charset="0"/>
+              </a:rPr>
+              <a:t/>
+            </a:r>
+            <a:r>
+              <a:rPr dirty="0" err="1">
+                <a:latin typeface="Times New Roman" panose="02020603050405020304" pitchFamily="18" charset="0"/>
+                <a:cs typeface="Times New Roman" panose="02020603050405020304" pitchFamily="18" charset="0"/>
+              </a:rPr>
+              <a:t/>
+            </a:r>
+            <a:r>
+              <a:rPr dirty="0">
+                <a:latin typeface="Times New Roman" panose="02020603050405020304" pitchFamily="18" charset="0"/>
+                <a:cs typeface="Times New Roman" panose="02020603050405020304" pitchFamily="18" charset="0"/>
+              </a:rPr>
+              <a:t/>
+            </a:r>
+            <a:r>
+              <a:rPr dirty="0" err="1">
+                <a:latin typeface="Times New Roman" panose="02020603050405020304" pitchFamily="18" charset="0"/>
+                <a:cs typeface="Times New Roman" panose="02020603050405020304" pitchFamily="18" charset="0"/>
+              </a:rPr>
+              <a:t/>
+            </a:r>
+            <a:r>
+              <a:rPr dirty="0">
+                <a:latin typeface="Times New Roman" panose="02020603050405020304" pitchFamily="18" charset="0"/>
+                <a:cs typeface="Times New Roman" panose="02020603050405020304" pitchFamily="18" charset="0"/>
+              </a:rPr>
+              <a:t/>
             </a:r>
           </a:p>
           <a:p>
@@ -10432,49 +10101,49 @@
                 <a:latin typeface="Times New Roman" panose="02020603050405020304" pitchFamily="18" charset="0"/>
                 <a:cs typeface="Times New Roman" panose="02020603050405020304" pitchFamily="18" charset="0"/>
               </a:rPr>
-              <a:t>285 </a:t>
-            </a:r>
-            <a:r>
-              <a:rPr dirty="0" err="1">
-                <a:latin typeface="Times New Roman" panose="02020603050405020304" pitchFamily="18" charset="0"/>
-                <a:cs typeface="Times New Roman" panose="02020603050405020304" pitchFamily="18" charset="0"/>
-              </a:rPr>
-              <a:t>Γρ</a:t>
-            </a:r>
-            <a:r>
-              <a:rPr dirty="0">
-                <a:latin typeface="Times New Roman" panose="02020603050405020304" pitchFamily="18" charset="0"/>
-                <a:cs typeface="Times New Roman" panose="02020603050405020304" pitchFamily="18" charset="0"/>
-              </a:rPr>
-              <a:t>α</a:t>
-            </a:r>
-            <a:r>
-              <a:rPr dirty="0" err="1">
-                <a:latin typeface="Times New Roman" panose="02020603050405020304" pitchFamily="18" charset="0"/>
-                <a:cs typeface="Times New Roman" panose="02020603050405020304" pitchFamily="18" charset="0"/>
-              </a:rPr>
-              <a:t>μμές</a:t>
-            </a:r>
-            <a:r>
-              <a:rPr dirty="0">
-                <a:latin typeface="Times New Roman" panose="02020603050405020304" pitchFamily="18" charset="0"/>
-                <a:cs typeface="Times New Roman" panose="02020603050405020304" pitchFamily="18" charset="0"/>
-              </a:rPr>
-              <a:t> </a:t>
-            </a:r>
-            <a:r>
-              <a:rPr dirty="0" err="1">
-                <a:latin typeface="Times New Roman" panose="02020603050405020304" pitchFamily="18" charset="0"/>
-                <a:cs typeface="Times New Roman" panose="02020603050405020304" pitchFamily="18" charset="0"/>
-              </a:rPr>
-              <a:t>Κώδικ</a:t>
-            </a:r>
-            <a:r>
-              <a:rPr dirty="0">
-                <a:latin typeface="Times New Roman" panose="02020603050405020304" pitchFamily="18" charset="0"/>
-                <a:cs typeface="Times New Roman" panose="02020603050405020304" pitchFamily="18" charset="0"/>
-              </a:rPr>
-              <a:t>α</a:t>
+              <a:t>406 Γραμμές Κώδικα</a:t>
+            </a:r>
+            <a:r>
+              <a:rPr dirty="0" err="1">
+                <a:latin typeface="Times New Roman" panose="02020603050405020304" pitchFamily="18" charset="0"/>
+                <a:cs typeface="Times New Roman" panose="02020603050405020304" pitchFamily="18" charset="0"/>
+              </a:rPr>
+              <a:t/>
+            </a:r>
+            <a:r>
+              <a:rPr dirty="0">
+                <a:latin typeface="Times New Roman" panose="02020603050405020304" pitchFamily="18" charset="0"/>
+                <a:cs typeface="Times New Roman" panose="02020603050405020304" pitchFamily="18" charset="0"/>
+              </a:rPr>
+              <a:t/>
+            </a:r>
+            <a:r>
+              <a:rPr dirty="0" err="1">
+                <a:latin typeface="Times New Roman" panose="02020603050405020304" pitchFamily="18" charset="0"/>
+                <a:cs typeface="Times New Roman" panose="02020603050405020304" pitchFamily="18" charset="0"/>
+              </a:rPr>
+              <a:t/>
+            </a:r>
+            <a:r>
+              <a:rPr dirty="0">
+                <a:latin typeface="Times New Roman" panose="02020603050405020304" pitchFamily="18" charset="0"/>
+                <a:cs typeface="Times New Roman" panose="02020603050405020304" pitchFamily="18" charset="0"/>
+              </a:rPr>
+              <a:t/>
+            </a:r>
+            <a:r>
+              <a:rPr dirty="0" err="1">
+                <a:latin typeface="Times New Roman" panose="02020603050405020304" pitchFamily="18" charset="0"/>
+                <a:cs typeface="Times New Roman" panose="02020603050405020304" pitchFamily="18" charset="0"/>
+              </a:rPr>
+              <a:t/>
+            </a:r>
+            <a:r>
+              <a:rPr dirty="0">
+                <a:latin typeface="Times New Roman" panose="02020603050405020304" pitchFamily="18" charset="0"/>
+                <a:cs typeface="Times New Roman" panose="02020603050405020304" pitchFamily="18" charset="0"/>
+              </a:rPr>
+              <a:t/>
             </a:r>
           </a:p>
           <a:p>
@@ -10657,49 +10326,49 @@
                 <a:latin typeface="Times New Roman" panose="02020603050405020304" pitchFamily="18" charset="0"/>
                 <a:cs typeface="Times New Roman" panose="02020603050405020304" pitchFamily="18" charset="0"/>
               </a:rPr>
-              <a:t>35 </a:t>
-            </a:r>
-            <a:r>
-              <a:rPr dirty="0" err="1">
-                <a:latin typeface="Times New Roman" panose="02020603050405020304" pitchFamily="18" charset="0"/>
-                <a:cs typeface="Times New Roman" panose="02020603050405020304" pitchFamily="18" charset="0"/>
-              </a:rPr>
-              <a:t>Γρ</a:t>
-            </a:r>
-            <a:r>
-              <a:rPr dirty="0">
-                <a:latin typeface="Times New Roman" panose="02020603050405020304" pitchFamily="18" charset="0"/>
-                <a:cs typeface="Times New Roman" panose="02020603050405020304" pitchFamily="18" charset="0"/>
-              </a:rPr>
-              <a:t>α</a:t>
-            </a:r>
-            <a:r>
-              <a:rPr dirty="0" err="1">
-                <a:latin typeface="Times New Roman" panose="02020603050405020304" pitchFamily="18" charset="0"/>
-                <a:cs typeface="Times New Roman" panose="02020603050405020304" pitchFamily="18" charset="0"/>
-              </a:rPr>
-              <a:t>μμές</a:t>
-            </a:r>
-            <a:r>
-              <a:rPr dirty="0">
-                <a:latin typeface="Times New Roman" panose="02020603050405020304" pitchFamily="18" charset="0"/>
-                <a:cs typeface="Times New Roman" panose="02020603050405020304" pitchFamily="18" charset="0"/>
-              </a:rPr>
-              <a:t> </a:t>
-            </a:r>
-            <a:r>
-              <a:rPr dirty="0" err="1">
-                <a:latin typeface="Times New Roman" panose="02020603050405020304" pitchFamily="18" charset="0"/>
-                <a:cs typeface="Times New Roman" panose="02020603050405020304" pitchFamily="18" charset="0"/>
-              </a:rPr>
-              <a:t>Κώδικ</a:t>
-            </a:r>
-            <a:r>
-              <a:rPr dirty="0">
-                <a:latin typeface="Times New Roman" panose="02020603050405020304" pitchFamily="18" charset="0"/>
-                <a:cs typeface="Times New Roman" panose="02020603050405020304" pitchFamily="18" charset="0"/>
-              </a:rPr>
-              <a:t>α</a:t>
+              <a:t>25 Γραμμές Κώδικα</a:t>
+            </a:r>
+            <a:r>
+              <a:rPr dirty="0" err="1">
+                <a:latin typeface="Times New Roman" panose="02020603050405020304" pitchFamily="18" charset="0"/>
+                <a:cs typeface="Times New Roman" panose="02020603050405020304" pitchFamily="18" charset="0"/>
+              </a:rPr>
+              <a:t/>
+            </a:r>
+            <a:r>
+              <a:rPr dirty="0">
+                <a:latin typeface="Times New Roman" panose="02020603050405020304" pitchFamily="18" charset="0"/>
+                <a:cs typeface="Times New Roman" panose="02020603050405020304" pitchFamily="18" charset="0"/>
+              </a:rPr>
+              <a:t/>
+            </a:r>
+            <a:r>
+              <a:rPr dirty="0" err="1">
+                <a:latin typeface="Times New Roman" panose="02020603050405020304" pitchFamily="18" charset="0"/>
+                <a:cs typeface="Times New Roman" panose="02020603050405020304" pitchFamily="18" charset="0"/>
+              </a:rPr>
+              <a:t/>
+            </a:r>
+            <a:r>
+              <a:rPr dirty="0">
+                <a:latin typeface="Times New Roman" panose="02020603050405020304" pitchFamily="18" charset="0"/>
+                <a:cs typeface="Times New Roman" panose="02020603050405020304" pitchFamily="18" charset="0"/>
+              </a:rPr>
+              <a:t/>
+            </a:r>
+            <a:r>
+              <a:rPr dirty="0" err="1">
+                <a:latin typeface="Times New Roman" panose="02020603050405020304" pitchFamily="18" charset="0"/>
+                <a:cs typeface="Times New Roman" panose="02020603050405020304" pitchFamily="18" charset="0"/>
+              </a:rPr>
+              <a:t/>
+            </a:r>
+            <a:r>
+              <a:rPr dirty="0">
+                <a:latin typeface="Times New Roman" panose="02020603050405020304" pitchFamily="18" charset="0"/>
+                <a:cs typeface="Times New Roman" panose="02020603050405020304" pitchFamily="18" charset="0"/>
+              </a:rPr>
+              <a:t/>
             </a:r>
           </a:p>
           <a:p>
@@ -12767,7 +12436,7 @@
         <p:spPr>
           <a:xfrm>
             <a:off x="731520" y="1691640"/>
-            <a:ext cx="5166360" cy="4663440"/>
+            <a:ext cx="5852160" cy="2560320"/>
           </a:xfrm>
           <a:prstGeom prst="roundRect">
             <a:avLst/>
@@ -12875,7 +12544,7 @@
               <a:spcAft>
                 <a:spcPts val="900"/>
               </a:spcAft>
-              <a:defRPr sz="1300">
+              <a:defRPr sz="1200">
                 <a:solidFill>
                   <a:srgbClr val="DCE2EB"/>
                 </a:solidFill>
@@ -13020,7 +12689,7 @@
               <a:spcAft>
                 <a:spcPts val="900"/>
               </a:spcAft>
-              <a:defRPr sz="1300">
+              <a:defRPr sz="1200">
                 <a:solidFill>
                   <a:srgbClr val="DCE2EB"/>
                 </a:solidFill>
@@ -13221,7 +12890,7 @@
               <a:spcAft>
                 <a:spcPts val="900"/>
               </a:spcAft>
-              <a:defRPr sz="1300">
+              <a:defRPr sz="1200">
                 <a:solidFill>
                   <a:srgbClr val="DCE2EB"/>
                 </a:solidFill>
@@ -13422,7 +13091,7 @@
               <a:spcAft>
                 <a:spcPts val="900"/>
               </a:spcAft>
-              <a:defRPr sz="1300">
+              <a:defRPr sz="1200">
                 <a:solidFill>
                   <a:srgbClr val="DCE2EB"/>
                 </a:solidFill>
@@ -13609,7 +13278,7 @@
               <a:spcAft>
                 <a:spcPts val="900"/>
               </a:spcAft>
-              <a:defRPr sz="1300">
+              <a:defRPr sz="1200">
                 <a:solidFill>
                   <a:srgbClr val="DCE2EB"/>
                 </a:solidFill>
@@ -13787,8 +13456,8 @@
         </p:nvSpPr>
         <p:spPr>
           <a:xfrm>
-            <a:off x="6263640" y="1691640"/>
-            <a:ext cx="5166360" cy="4663440"/>
+            <a:off x="731520" y="4389120"/>
+            <a:ext cx="5852160" cy="1965960"/>
           </a:xfrm>
           <a:prstGeom prst="roundRect">
             <a:avLst/>
@@ -13913,7 +13582,7 @@
               <a:spcAft>
                 <a:spcPts val="900"/>
               </a:spcAft>
-              <a:defRPr sz="1300">
+              <a:defRPr sz="1200">
                 <a:solidFill>
                   <a:srgbClr val="DCE2EB"/>
                 </a:solidFill>
@@ -14142,7 +13811,7 @@
               <a:spcAft>
                 <a:spcPts val="900"/>
               </a:spcAft>
-              <a:defRPr sz="1300">
+              <a:defRPr sz="1200">
                 <a:solidFill>
                   <a:srgbClr val="DCE2EB"/>
                 </a:solidFill>
@@ -14315,7 +13984,7 @@
               <a:spcAft>
                 <a:spcPts val="900"/>
               </a:spcAft>
-              <a:defRPr sz="1300">
+              <a:defRPr sz="1200">
                 <a:solidFill>
                   <a:srgbClr val="DCE2EB"/>
                 </a:solidFill>
@@ -14481,6 +14150,65 @@
                 <a:cs typeface="Times New Roman" panose="02020603050405020304" pitchFamily="18" charset="0"/>
               </a:rPr>
               <a:t>.</a:t>
+            </a:r>
+          </a:p>
+        </p:txBody>
+      </p:sp>
+      <p:pic>
+        <p:nvPicPr>
+          <p:cNvPr id="8" name="Picture 7" descr="image1.png"/>
+          <p:cNvPicPr>
+            <a:picLocks noChangeAspect="1"/>
+          </p:cNvPicPr>
+          <p:nvPr/>
+        </p:nvPicPr>
+        <p:blipFill>
+          <a:blip r:embed="rId3"/>
+          <a:stretch>
+            <a:fillRect/>
+          </a:stretch>
+        </p:blipFill>
+        <p:spPr>
+          <a:xfrm>
+            <a:off x="6858000" y="1691640"/>
+            <a:ext cx="4572000" cy="4023360"/>
+          </a:xfrm>
+          <a:prstGeom prst="rect">
+            <a:avLst/>
+          </a:prstGeom>
+        </p:spPr>
+      </p:pic>
+      <p:sp>
+        <p:nvSpPr>
+          <p:cNvPr id="9" name="TextBox 8"/>
+          <p:cNvSpPr txBox="1"/>
+          <p:nvPr/>
+        </p:nvSpPr>
+        <p:spPr>
+          <a:xfrm>
+            <a:off x="6858000" y="5779008"/>
+            <a:ext cx="4572000" cy="502920"/>
+          </a:xfrm>
+          <a:prstGeom prst="rect">
+            <a:avLst/>
+          </a:prstGeom>
+          <a:noFill/>
+        </p:spPr>
+        <p:txBody>
+          <a:bodyPr wrap="square">
+            <a:spAutoFit/>
+          </a:bodyPr>
+          <a:lstStyle/>
+          <a:p>
+            <a:pPr algn="ctr">
+              <a:defRPr sz="1100">
+                <a:solidFill>
+                  <a:srgbClr val="D4AF37"/>
+                </a:solidFill>
+              </a:defRPr>
+            </a:pPr>
+            <a:r>
+              <a:t>📷 In-Game: Ο ατμοσφαιρικός 3D χώρος της βιβλιοθήκης</a:t>
             </a:r>
           </a:p>
         </p:txBody>
@@ -21184,7 +20912,7 @@
                 <a:latin typeface="Times New Roman" panose="02020603050405020304" pitchFamily="18" charset="0"/>
                 <a:cs typeface="Times New Roman" panose="02020603050405020304" pitchFamily="18" charset="0"/>
               </a:rPr>
-              <a:t> 2.5 </a:t>
+              <a:t> 3.0 </a:t>
             </a:r>
             <a:r>
               <a:rPr dirty="0" err="1">
@@ -22317,7 +22045,7 @@
                 <a:latin typeface="Times New Roman" panose="02020603050405020304" pitchFamily="18" charset="0"/>
                 <a:cs typeface="Times New Roman" panose="02020603050405020304" pitchFamily="18" charset="0"/>
               </a:rPr>
-              <a:t> (🫱) </a:t>
+              <a:t> (✋) </a:t>
             </a:r>
             <a:r>
               <a:rPr dirty="0" err="1">
@@ -23039,8 +22767,8 @@
         </p:nvSpPr>
         <p:spPr>
           <a:xfrm>
-            <a:off x="661852" y="1691640"/>
-            <a:ext cx="5166360" cy="4663440"/>
+            <a:off x="731520" y="1691640"/>
+            <a:ext cx="5852160" cy="2240280"/>
           </a:xfrm>
           <a:prstGeom prst="roundRect">
             <a:avLst/>
@@ -23148,7 +22876,7 @@
               <a:spcAft>
                 <a:spcPts val="900"/>
               </a:spcAft>
-              <a:defRPr sz="1300">
+              <a:defRPr sz="1200">
                 <a:solidFill>
                   <a:srgbClr val="DCE2EB"/>
                 </a:solidFill>
@@ -23349,7 +23077,7 @@
               <a:spcAft>
                 <a:spcPts val="900"/>
               </a:spcAft>
-              <a:defRPr sz="1300">
+              <a:defRPr sz="1200">
                 <a:solidFill>
                   <a:srgbClr val="DCE2EB"/>
                 </a:solidFill>
@@ -23536,7 +23264,7 @@
               <a:spcAft>
                 <a:spcPts val="900"/>
               </a:spcAft>
-              <a:defRPr sz="1300">
+              <a:defRPr sz="1200">
                 <a:solidFill>
                   <a:srgbClr val="DCE2EB"/>
                 </a:solidFill>
@@ -23667,7 +23395,7 @@
               <a:spcAft>
                 <a:spcPts val="900"/>
               </a:spcAft>
-              <a:defRPr sz="1300">
+              <a:defRPr sz="1200">
                 <a:solidFill>
                   <a:srgbClr val="DCE2EB"/>
                 </a:solidFill>
@@ -23901,8 +23629,8 @@
         </p:nvSpPr>
         <p:spPr>
           <a:xfrm>
-            <a:off x="6263640" y="1691640"/>
-            <a:ext cx="5166360" cy="4663440"/>
+            <a:off x="731520" y="4069080"/>
+            <a:ext cx="5852160" cy="2286000"/>
           </a:xfrm>
           <a:prstGeom prst="roundRect">
             <a:avLst/>
@@ -24010,7 +23738,7 @@
               <a:spcAft>
                 <a:spcPts val="900"/>
               </a:spcAft>
-              <a:defRPr sz="1300">
+              <a:defRPr sz="1200">
                 <a:solidFill>
                   <a:srgbClr val="DCE2EB"/>
                 </a:solidFill>
@@ -24169,7 +23897,7 @@
               <a:spcAft>
                 <a:spcPts val="900"/>
               </a:spcAft>
-              <a:defRPr sz="1300">
+              <a:defRPr sz="1200">
                 <a:solidFill>
                   <a:srgbClr val="DCE2EB"/>
                 </a:solidFill>
@@ -24328,7 +24056,7 @@
               <a:spcAft>
                 <a:spcPts val="900"/>
               </a:spcAft>
-              <a:defRPr sz="1300">
+              <a:defRPr sz="1200">
                 <a:solidFill>
                   <a:srgbClr val="DCE2EB"/>
                 </a:solidFill>
@@ -24571,7 +24299,7 @@
               <a:spcAft>
                 <a:spcPts val="900"/>
               </a:spcAft>
-              <a:defRPr sz="1300">
+              <a:defRPr sz="1200">
                 <a:solidFill>
                   <a:srgbClr val="DCE2EB"/>
                 </a:solidFill>
@@ -24737,6 +24465,65 @@
                 <a:cs typeface="Times New Roman" panose="02020603050405020304" pitchFamily="18" charset="0"/>
               </a:rPr>
               <a:t>.</a:t>
+            </a:r>
+          </a:p>
+        </p:txBody>
+      </p:sp>
+      <p:pic>
+        <p:nvPicPr>
+          <p:cNvPr id="8" name="Picture 7" descr="image2.png"/>
+          <p:cNvPicPr>
+            <a:picLocks noChangeAspect="1"/>
+          </p:cNvPicPr>
+          <p:nvPr/>
+        </p:nvPicPr>
+        <p:blipFill>
+          <a:blip r:embed="rId3"/>
+          <a:stretch>
+            <a:fillRect/>
+          </a:stretch>
+        </p:blipFill>
+        <p:spPr>
+          <a:xfrm>
+            <a:off x="6858000" y="1691640"/>
+            <a:ext cx="4572000" cy="4023360"/>
+          </a:xfrm>
+          <a:prstGeom prst="rect">
+            <a:avLst/>
+          </a:prstGeom>
+        </p:spPr>
+      </p:pic>
+      <p:sp>
+        <p:nvSpPr>
+          <p:cNvPr id="9" name="TextBox 8"/>
+          <p:cNvSpPr txBox="1"/>
+          <p:nvPr/>
+        </p:nvSpPr>
+        <p:spPr>
+          <a:xfrm>
+            <a:off x="6858000" y="5779008"/>
+            <a:ext cx="4572000" cy="502920"/>
+          </a:xfrm>
+          <a:prstGeom prst="rect">
+            <a:avLst/>
+          </a:prstGeom>
+          <a:noFill/>
+        </p:spPr>
+        <p:txBody>
+          <a:bodyPr wrap="square">
+            <a:spAutoFit/>
+          </a:bodyPr>
+          <a:lstStyle/>
+          <a:p>
+            <a:pPr algn="ctr">
+              <a:defRPr sz="1100">
+                <a:solidFill>
+                  <a:srgbClr val="D4AF37"/>
+                </a:solidFill>
+              </a:defRPr>
+            </a:pPr>
+            <a:r>
+              <a:t>📷 In-Game: Οι 3 κρύσταλλοι &amp; τα μυστικά βιβλία</a:t>
             </a:r>
           </a:p>
         </p:txBody>
@@ -25088,7 +24875,7 @@
         <p:spPr>
           <a:xfrm>
             <a:off x="731520" y="1691640"/>
-            <a:ext cx="5166360" cy="4663440"/>
+            <a:ext cx="5852160" cy="2240280"/>
           </a:xfrm>
           <a:prstGeom prst="roundRect">
             <a:avLst/>
@@ -25238,7 +25025,7 @@
               <a:spcAft>
                 <a:spcPts val="900"/>
               </a:spcAft>
-              <a:defRPr sz="1300">
+              <a:defRPr sz="1200">
                 <a:solidFill>
                   <a:srgbClr val="DCE2EB"/>
                 </a:solidFill>
@@ -25481,7 +25268,7 @@
               <a:spcAft>
                 <a:spcPts val="900"/>
               </a:spcAft>
-              <a:defRPr sz="1300">
+              <a:defRPr sz="1200">
                 <a:solidFill>
                   <a:srgbClr val="DCE2EB"/>
                 </a:solidFill>
@@ -25654,7 +25441,7 @@
               <a:spcAft>
                 <a:spcPts val="900"/>
               </a:spcAft>
-              <a:defRPr sz="1300">
+              <a:defRPr sz="1200">
                 <a:solidFill>
                   <a:srgbClr val="DCE2EB"/>
                 </a:solidFill>
@@ -25869,7 +25656,7 @@
               <a:spcAft>
                 <a:spcPts val="900"/>
               </a:spcAft>
-              <a:defRPr sz="1300">
+              <a:defRPr sz="1200">
                 <a:solidFill>
                   <a:srgbClr val="DCE2EB"/>
                 </a:solidFill>
@@ -26061,8 +25848,8 @@
         </p:nvSpPr>
         <p:spPr>
           <a:xfrm>
-            <a:off x="6263640" y="1691640"/>
-            <a:ext cx="5166360" cy="4663440"/>
+            <a:off x="731520" y="4069080"/>
+            <a:ext cx="5852160" cy="2286000"/>
           </a:xfrm>
           <a:prstGeom prst="roundRect">
             <a:avLst/>
@@ -26145,7 +25932,7 @@
               <a:spcAft>
                 <a:spcPts val="900"/>
               </a:spcAft>
-              <a:defRPr sz="1300">
+              <a:defRPr sz="1200">
                 <a:solidFill>
                   <a:srgbClr val="DCE2EB"/>
                 </a:solidFill>
@@ -26248,7 +26035,7 @@
               <a:spcAft>
                 <a:spcPts val="900"/>
               </a:spcAft>
-              <a:defRPr sz="1300">
+              <a:defRPr sz="1200">
                 <a:solidFill>
                   <a:srgbClr val="DCE2EB"/>
                 </a:solidFill>
@@ -26491,7 +26278,7 @@
               <a:spcAft>
                 <a:spcPts val="900"/>
               </a:spcAft>
-              <a:defRPr sz="1300">
+              <a:defRPr sz="1200">
                 <a:solidFill>
                   <a:srgbClr val="DCE2EB"/>
                 </a:solidFill>
@@ -26776,7 +26563,7 @@
               <a:spcAft>
                 <a:spcPts val="900"/>
               </a:spcAft>
-              <a:defRPr sz="1300">
+              <a:defRPr sz="1200">
                 <a:solidFill>
                   <a:srgbClr val="DCE2EB"/>
                 </a:solidFill>
@@ -26998,6 +26785,65 @@
                 <a:cs typeface="Times New Roman" panose="02020603050405020304" pitchFamily="18" charset="0"/>
               </a:rPr>
               <a:t>.</a:t>
+            </a:r>
+          </a:p>
+        </p:txBody>
+      </p:sp>
+      <p:pic>
+        <p:nvPicPr>
+          <p:cNvPr id="8" name="Picture 7" descr="image3.png"/>
+          <p:cNvPicPr>
+            <a:picLocks noChangeAspect="1"/>
+          </p:cNvPicPr>
+          <p:nvPr/>
+        </p:nvPicPr>
+        <p:blipFill>
+          <a:blip r:embed="rId3"/>
+          <a:stretch>
+            <a:fillRect/>
+          </a:stretch>
+        </p:blipFill>
+        <p:spPr>
+          <a:xfrm>
+            <a:off x="6858000" y="1691640"/>
+            <a:ext cx="4572000" cy="4023360"/>
+          </a:xfrm>
+          <a:prstGeom prst="rect">
+            <a:avLst/>
+          </a:prstGeom>
+        </p:spPr>
+      </p:pic>
+      <p:sp>
+        <p:nvSpPr>
+          <p:cNvPr id="9" name="TextBox 8"/>
+          <p:cNvSpPr txBox="1"/>
+          <p:nvPr/>
+        </p:nvSpPr>
+        <p:spPr>
+          <a:xfrm>
+            <a:off x="6858000" y="5779008"/>
+            <a:ext cx="4572000" cy="502920"/>
+          </a:xfrm>
+          <a:prstGeom prst="rect">
+            <a:avLst/>
+          </a:prstGeom>
+          <a:noFill/>
+        </p:spPr>
+        <p:txBody>
+          <a:bodyPr wrap="square">
+            <a:spAutoFit/>
+          </a:bodyPr>
+          <a:lstStyle/>
+          <a:p>
+            <a:pPr algn="ctr">
+              <a:defRPr sz="1100">
+                <a:solidFill>
+                  <a:srgbClr val="D4AF37"/>
+                </a:solidFill>
+              </a:defRPr>
+            </a:pPr>
+            <a:r>
+              <a:t>📷 In-Game: Το γεωμετρικό παζλ τριγώνου στο τραπέζι</a:t>
             </a:r>
           </a:p>
         </p:txBody>

</xml_diff>